<commit_message>
Rewrite Lab 3 against the system as it actually is
Part 1 was eleven strengths and twelve gaps, and several gaps were developer
chores rather than anything a client would recognise. It is now five and five,
each opportunity a customer-facing consequence that Part 2 then fixes in order.

Part 2 had invented its own headings and described finished work, which is not a
plan. It now uses the areas the exercise names, branding through engagement, and
each row states what is already built and what still has to be done.

Part 4 was a log of completed tasks with past dates. It is now a plan for
developing the system, twelve stages, each ending in something that can be shown
so progress is never only a claim.

The figure list claimed twenty-one screens when thirty-three existed and two
shared the number 31. Every citation now points at a file that exists, and the
three screens the worksheet referenced but nobody had captured are included.
</commit_message>
<xml_diff>
--- a/docs/Lab3-Bencris-Presentation.pptx
+++ b/docs/Lab3-Bencris-Presentation.pptx
@@ -137,7 +137,7 @@
           <p:cNvPr id="2" name="Title 1">
             <a:extLst>
               <a:ext uri="{FF2B5EF4-FFF2-40B4-BE49-F238E27FC236}">
-                <a16:creationId xmlns:a16="http://schemas.microsoft.com/office/drawing/2014/main" id="{8832B2A4-A6B5-FF8A-5D99-C11FB2D558E3}"/>
+                <a16:creationId xmlns:a16="http://schemas.microsoft.com/office/drawing/2014/main" id="{08C7FE34-0EAF-5C08-40CF-D0AF38E8778C}"/>
               </a:ext>
             </a:extLst>
           </p:cNvPr>
@@ -175,7 +175,7 @@
           <p:cNvPr id="3" name="Subtitle 2">
             <a:extLst>
               <a:ext uri="{FF2B5EF4-FFF2-40B4-BE49-F238E27FC236}">
-                <a16:creationId xmlns:a16="http://schemas.microsoft.com/office/drawing/2014/main" id="{7317F3C6-034B-EACD-1497-C799B8207280}"/>
+                <a16:creationId xmlns:a16="http://schemas.microsoft.com/office/drawing/2014/main" id="{05D4D5C2-160E-8AD9-383A-889BA450741B}"/>
               </a:ext>
             </a:extLst>
           </p:cNvPr>
@@ -246,7 +246,7 @@
           <p:cNvPr id="4" name="Date Placeholder 3">
             <a:extLst>
               <a:ext uri="{FF2B5EF4-FFF2-40B4-BE49-F238E27FC236}">
-                <a16:creationId xmlns:a16="http://schemas.microsoft.com/office/drawing/2014/main" id="{514120FE-78E9-D8BF-F368-180742AFE51E}"/>
+                <a16:creationId xmlns:a16="http://schemas.microsoft.com/office/drawing/2014/main" id="{17E213B3-17E9-85D7-21EE-2094BC197DA5}"/>
               </a:ext>
             </a:extLst>
           </p:cNvPr>
@@ -262,9 +262,9 @@
           <a:bodyPr/>
           <a:lstStyle/>
           <a:p>
-            <a:fld id="{B9C08E97-6EF3-448D-8F45-4AAD37A7D186}" type="datetimeFigureOut">
+            <a:fld id="{DDB4EC1F-5F29-4B45-A1E9-4711EF87C999}" type="datetimeFigureOut">
               <a:rPr lang="en-PH" smtClean="0"/>
-              <a:t>8/6/2026</a:t>
+              <a:t>8/7/2026</a:t>
             </a:fld>
             <a:endParaRPr lang="en-PH"/>
           </a:p>
@@ -275,7 +275,7 @@
           <p:cNvPr id="5" name="Footer Placeholder 4">
             <a:extLst>
               <a:ext uri="{FF2B5EF4-FFF2-40B4-BE49-F238E27FC236}">
-                <a16:creationId xmlns:a16="http://schemas.microsoft.com/office/drawing/2014/main" id="{517ED6A7-2B39-3BC4-A0F7-BC8C6AB4B326}"/>
+                <a16:creationId xmlns:a16="http://schemas.microsoft.com/office/drawing/2014/main" id="{521A5DF1-5ED7-E438-7CF4-EB1D66FF9624}"/>
               </a:ext>
             </a:extLst>
           </p:cNvPr>
@@ -300,7 +300,7 @@
           <p:cNvPr id="6" name="Slide Number Placeholder 5">
             <a:extLst>
               <a:ext uri="{FF2B5EF4-FFF2-40B4-BE49-F238E27FC236}">
-                <a16:creationId xmlns:a16="http://schemas.microsoft.com/office/drawing/2014/main" id="{A767866F-B82C-5D6D-3248-92F2E5696418}"/>
+                <a16:creationId xmlns:a16="http://schemas.microsoft.com/office/drawing/2014/main" id="{BB786B76-B5AC-AABE-AFA8-6F7780FDE9BD}"/>
               </a:ext>
             </a:extLst>
           </p:cNvPr>
@@ -316,7 +316,7 @@
           <a:bodyPr/>
           <a:lstStyle/>
           <a:p>
-            <a:fld id="{B655F8A7-5DB9-4992-95EB-512B135CD058}" type="slidenum">
+            <a:fld id="{7FA8160B-192F-41E7-ADA4-0A7DED088FC5}" type="slidenum">
               <a:rPr lang="en-PH" smtClean="0"/>
               <a:t>‹#›</a:t>
             </a:fld>
@@ -327,7 +327,7 @@
     </p:spTree>
     <p:extLst>
       <p:ext uri="{BB962C8B-B14F-4D97-AF65-F5344CB8AC3E}">
-        <p14:creationId xmlns:p14="http://schemas.microsoft.com/office/powerpoint/2010/main" val="2022259872"/>
+        <p14:creationId xmlns:p14="http://schemas.microsoft.com/office/powerpoint/2010/main" val="520612691"/>
       </p:ext>
     </p:extLst>
   </p:cSld>
@@ -359,7 +359,7 @@
           <p:cNvPr id="2" name="Title 1">
             <a:extLst>
               <a:ext uri="{FF2B5EF4-FFF2-40B4-BE49-F238E27FC236}">
-                <a16:creationId xmlns:a16="http://schemas.microsoft.com/office/drawing/2014/main" id="{FB2AF2E0-65D4-529C-3DD6-D821E4935504}"/>
+                <a16:creationId xmlns:a16="http://schemas.microsoft.com/office/drawing/2014/main" id="{07CB8222-0D45-03E1-7DE9-FC3CF99F93EC}"/>
               </a:ext>
             </a:extLst>
           </p:cNvPr>
@@ -388,7 +388,7 @@
           <p:cNvPr id="3" name="Vertical Text Placeholder 2">
             <a:extLst>
               <a:ext uri="{FF2B5EF4-FFF2-40B4-BE49-F238E27FC236}">
-                <a16:creationId xmlns:a16="http://schemas.microsoft.com/office/drawing/2014/main" id="{51D16F45-84D6-EDDE-CB95-2EBEF30EB39E}"/>
+                <a16:creationId xmlns:a16="http://schemas.microsoft.com/office/drawing/2014/main" id="{B71D9222-2233-E982-1E26-F29242E3FB1A}"/>
               </a:ext>
             </a:extLst>
           </p:cNvPr>
@@ -446,7 +446,7 @@
           <p:cNvPr id="4" name="Date Placeholder 3">
             <a:extLst>
               <a:ext uri="{FF2B5EF4-FFF2-40B4-BE49-F238E27FC236}">
-                <a16:creationId xmlns:a16="http://schemas.microsoft.com/office/drawing/2014/main" id="{974D8264-A326-E159-5E61-CB2A6147699A}"/>
+                <a16:creationId xmlns:a16="http://schemas.microsoft.com/office/drawing/2014/main" id="{1405F528-56D1-5E24-768C-E1B3BDB8C341}"/>
               </a:ext>
             </a:extLst>
           </p:cNvPr>
@@ -462,9 +462,9 @@
           <a:bodyPr/>
           <a:lstStyle/>
           <a:p>
-            <a:fld id="{B9C08E97-6EF3-448D-8F45-4AAD37A7D186}" type="datetimeFigureOut">
+            <a:fld id="{DDB4EC1F-5F29-4B45-A1E9-4711EF87C999}" type="datetimeFigureOut">
               <a:rPr lang="en-PH" smtClean="0"/>
-              <a:t>8/6/2026</a:t>
+              <a:t>8/7/2026</a:t>
             </a:fld>
             <a:endParaRPr lang="en-PH"/>
           </a:p>
@@ -475,7 +475,7 @@
           <p:cNvPr id="5" name="Footer Placeholder 4">
             <a:extLst>
               <a:ext uri="{FF2B5EF4-FFF2-40B4-BE49-F238E27FC236}">
-                <a16:creationId xmlns:a16="http://schemas.microsoft.com/office/drawing/2014/main" id="{E9592AFB-8DF8-DF47-7CAF-9D697A4A7E62}"/>
+                <a16:creationId xmlns:a16="http://schemas.microsoft.com/office/drawing/2014/main" id="{130B08B5-2BD2-D289-C013-874AF1A47302}"/>
               </a:ext>
             </a:extLst>
           </p:cNvPr>
@@ -500,7 +500,7 @@
           <p:cNvPr id="6" name="Slide Number Placeholder 5">
             <a:extLst>
               <a:ext uri="{FF2B5EF4-FFF2-40B4-BE49-F238E27FC236}">
-                <a16:creationId xmlns:a16="http://schemas.microsoft.com/office/drawing/2014/main" id="{BE86E708-86B4-2869-7E4D-251F43542FB7}"/>
+                <a16:creationId xmlns:a16="http://schemas.microsoft.com/office/drawing/2014/main" id="{4442F940-7934-47DE-8781-AA67CD2E087B}"/>
               </a:ext>
             </a:extLst>
           </p:cNvPr>
@@ -516,7 +516,7 @@
           <a:bodyPr/>
           <a:lstStyle/>
           <a:p>
-            <a:fld id="{B655F8A7-5DB9-4992-95EB-512B135CD058}" type="slidenum">
+            <a:fld id="{7FA8160B-192F-41E7-ADA4-0A7DED088FC5}" type="slidenum">
               <a:rPr lang="en-PH" smtClean="0"/>
               <a:t>‹#›</a:t>
             </a:fld>
@@ -527,7 +527,7 @@
     </p:spTree>
     <p:extLst>
       <p:ext uri="{BB962C8B-B14F-4D97-AF65-F5344CB8AC3E}">
-        <p14:creationId xmlns:p14="http://schemas.microsoft.com/office/powerpoint/2010/main" val="972011662"/>
+        <p14:creationId xmlns:p14="http://schemas.microsoft.com/office/powerpoint/2010/main" val="1365387884"/>
       </p:ext>
     </p:extLst>
   </p:cSld>
@@ -559,7 +559,7 @@
           <p:cNvPr id="2" name="Vertical Title 1">
             <a:extLst>
               <a:ext uri="{FF2B5EF4-FFF2-40B4-BE49-F238E27FC236}">
-                <a16:creationId xmlns:a16="http://schemas.microsoft.com/office/drawing/2014/main" id="{81810CEF-CCA1-201D-6CCF-8FB36791A394}"/>
+                <a16:creationId xmlns:a16="http://schemas.microsoft.com/office/drawing/2014/main" id="{84BB493C-AD50-B762-7861-905DFA4ED015}"/>
               </a:ext>
             </a:extLst>
           </p:cNvPr>
@@ -593,7 +593,7 @@
           <p:cNvPr id="3" name="Vertical Text Placeholder 2">
             <a:extLst>
               <a:ext uri="{FF2B5EF4-FFF2-40B4-BE49-F238E27FC236}">
-                <a16:creationId xmlns:a16="http://schemas.microsoft.com/office/drawing/2014/main" id="{62F8251D-A243-1453-9E65-23FC6F67707E}"/>
+                <a16:creationId xmlns:a16="http://schemas.microsoft.com/office/drawing/2014/main" id="{65C916B2-06B2-FD92-E0F8-99A7855D4329}"/>
               </a:ext>
             </a:extLst>
           </p:cNvPr>
@@ -656,7 +656,7 @@
           <p:cNvPr id="4" name="Date Placeholder 3">
             <a:extLst>
               <a:ext uri="{FF2B5EF4-FFF2-40B4-BE49-F238E27FC236}">
-                <a16:creationId xmlns:a16="http://schemas.microsoft.com/office/drawing/2014/main" id="{B67D544E-C42A-9316-646D-74ADA59F2DDA}"/>
+                <a16:creationId xmlns:a16="http://schemas.microsoft.com/office/drawing/2014/main" id="{4210E5A9-A0F0-F00F-74FF-2C528DD279C5}"/>
               </a:ext>
             </a:extLst>
           </p:cNvPr>
@@ -672,9 +672,9 @@
           <a:bodyPr/>
           <a:lstStyle/>
           <a:p>
-            <a:fld id="{B9C08E97-6EF3-448D-8F45-4AAD37A7D186}" type="datetimeFigureOut">
+            <a:fld id="{DDB4EC1F-5F29-4B45-A1E9-4711EF87C999}" type="datetimeFigureOut">
               <a:rPr lang="en-PH" smtClean="0"/>
-              <a:t>8/6/2026</a:t>
+              <a:t>8/7/2026</a:t>
             </a:fld>
             <a:endParaRPr lang="en-PH"/>
           </a:p>
@@ -685,7 +685,7 @@
           <p:cNvPr id="5" name="Footer Placeholder 4">
             <a:extLst>
               <a:ext uri="{FF2B5EF4-FFF2-40B4-BE49-F238E27FC236}">
-                <a16:creationId xmlns:a16="http://schemas.microsoft.com/office/drawing/2014/main" id="{613F43FA-3C81-5B10-6660-6403DA132455}"/>
+                <a16:creationId xmlns:a16="http://schemas.microsoft.com/office/drawing/2014/main" id="{9ACC05F9-3B90-7F11-F07E-CDEE5063E534}"/>
               </a:ext>
             </a:extLst>
           </p:cNvPr>
@@ -710,7 +710,7 @@
           <p:cNvPr id="6" name="Slide Number Placeholder 5">
             <a:extLst>
               <a:ext uri="{FF2B5EF4-FFF2-40B4-BE49-F238E27FC236}">
-                <a16:creationId xmlns:a16="http://schemas.microsoft.com/office/drawing/2014/main" id="{F5135237-6DA9-21F8-9DAB-ABAAABCC6300}"/>
+                <a16:creationId xmlns:a16="http://schemas.microsoft.com/office/drawing/2014/main" id="{B846826C-C997-64BC-7306-9CDD06F0260C}"/>
               </a:ext>
             </a:extLst>
           </p:cNvPr>
@@ -726,7 +726,7 @@
           <a:bodyPr/>
           <a:lstStyle/>
           <a:p>
-            <a:fld id="{B655F8A7-5DB9-4992-95EB-512B135CD058}" type="slidenum">
+            <a:fld id="{7FA8160B-192F-41E7-ADA4-0A7DED088FC5}" type="slidenum">
               <a:rPr lang="en-PH" smtClean="0"/>
               <a:t>‹#›</a:t>
             </a:fld>
@@ -737,7 +737,7 @@
     </p:spTree>
     <p:extLst>
       <p:ext uri="{BB962C8B-B14F-4D97-AF65-F5344CB8AC3E}">
-        <p14:creationId xmlns:p14="http://schemas.microsoft.com/office/powerpoint/2010/main" val="683733353"/>
+        <p14:creationId xmlns:p14="http://schemas.microsoft.com/office/powerpoint/2010/main" val="507646195"/>
       </p:ext>
     </p:extLst>
   </p:cSld>
@@ -769,7 +769,7 @@
           <p:cNvPr id="2" name="Title 1">
             <a:extLst>
               <a:ext uri="{FF2B5EF4-FFF2-40B4-BE49-F238E27FC236}">
-                <a16:creationId xmlns:a16="http://schemas.microsoft.com/office/drawing/2014/main" id="{816768F2-A69C-106C-E8F9-AA07EB34B89A}"/>
+                <a16:creationId xmlns:a16="http://schemas.microsoft.com/office/drawing/2014/main" id="{C4441AD2-426D-ADD4-9269-6CB43C9A2FFE}"/>
               </a:ext>
             </a:extLst>
           </p:cNvPr>
@@ -798,7 +798,7 @@
           <p:cNvPr id="3" name="Content Placeholder 2">
             <a:extLst>
               <a:ext uri="{FF2B5EF4-FFF2-40B4-BE49-F238E27FC236}">
-                <a16:creationId xmlns:a16="http://schemas.microsoft.com/office/drawing/2014/main" id="{72854B55-90D9-7D64-96DE-65F644752802}"/>
+                <a16:creationId xmlns:a16="http://schemas.microsoft.com/office/drawing/2014/main" id="{9A92DE07-A1C7-7EA3-1FC7-ACD003E7259A}"/>
               </a:ext>
             </a:extLst>
           </p:cNvPr>
@@ -856,7 +856,7 @@
           <p:cNvPr id="4" name="Date Placeholder 3">
             <a:extLst>
               <a:ext uri="{FF2B5EF4-FFF2-40B4-BE49-F238E27FC236}">
-                <a16:creationId xmlns:a16="http://schemas.microsoft.com/office/drawing/2014/main" id="{1137471F-D127-BD25-5F7E-DC0675670CEE}"/>
+                <a16:creationId xmlns:a16="http://schemas.microsoft.com/office/drawing/2014/main" id="{18D24D99-78B7-2215-E3BE-85C49C1797FD}"/>
               </a:ext>
             </a:extLst>
           </p:cNvPr>
@@ -872,9 +872,9 @@
           <a:bodyPr/>
           <a:lstStyle/>
           <a:p>
-            <a:fld id="{B9C08E97-6EF3-448D-8F45-4AAD37A7D186}" type="datetimeFigureOut">
+            <a:fld id="{DDB4EC1F-5F29-4B45-A1E9-4711EF87C999}" type="datetimeFigureOut">
               <a:rPr lang="en-PH" smtClean="0"/>
-              <a:t>8/6/2026</a:t>
+              <a:t>8/7/2026</a:t>
             </a:fld>
             <a:endParaRPr lang="en-PH"/>
           </a:p>
@@ -885,7 +885,7 @@
           <p:cNvPr id="5" name="Footer Placeholder 4">
             <a:extLst>
               <a:ext uri="{FF2B5EF4-FFF2-40B4-BE49-F238E27FC236}">
-                <a16:creationId xmlns:a16="http://schemas.microsoft.com/office/drawing/2014/main" id="{32EC0407-A842-5D75-7E2A-F08F3CDE13A7}"/>
+                <a16:creationId xmlns:a16="http://schemas.microsoft.com/office/drawing/2014/main" id="{55E76C75-07ED-3568-D442-6F144E4CBB4D}"/>
               </a:ext>
             </a:extLst>
           </p:cNvPr>
@@ -910,7 +910,7 @@
           <p:cNvPr id="6" name="Slide Number Placeholder 5">
             <a:extLst>
               <a:ext uri="{FF2B5EF4-FFF2-40B4-BE49-F238E27FC236}">
-                <a16:creationId xmlns:a16="http://schemas.microsoft.com/office/drawing/2014/main" id="{2EF7B643-A85D-E7CB-66B7-8EE6F95FDF22}"/>
+                <a16:creationId xmlns:a16="http://schemas.microsoft.com/office/drawing/2014/main" id="{0C863737-12E1-7419-2325-E705E94A25C8}"/>
               </a:ext>
             </a:extLst>
           </p:cNvPr>
@@ -926,7 +926,7 @@
           <a:bodyPr/>
           <a:lstStyle/>
           <a:p>
-            <a:fld id="{B655F8A7-5DB9-4992-95EB-512B135CD058}" type="slidenum">
+            <a:fld id="{7FA8160B-192F-41E7-ADA4-0A7DED088FC5}" type="slidenum">
               <a:rPr lang="en-PH" smtClean="0"/>
               <a:t>‹#›</a:t>
             </a:fld>
@@ -937,7 +937,7 @@
     </p:spTree>
     <p:extLst>
       <p:ext uri="{BB962C8B-B14F-4D97-AF65-F5344CB8AC3E}">
-        <p14:creationId xmlns:p14="http://schemas.microsoft.com/office/powerpoint/2010/main" val="1390967147"/>
+        <p14:creationId xmlns:p14="http://schemas.microsoft.com/office/powerpoint/2010/main" val="2356328888"/>
       </p:ext>
     </p:extLst>
   </p:cSld>
@@ -969,7 +969,7 @@
           <p:cNvPr id="2" name="Title 1">
             <a:extLst>
               <a:ext uri="{FF2B5EF4-FFF2-40B4-BE49-F238E27FC236}">
-                <a16:creationId xmlns:a16="http://schemas.microsoft.com/office/drawing/2014/main" id="{50B3B858-99A8-D135-F456-D8E2FFBD9A71}"/>
+                <a16:creationId xmlns:a16="http://schemas.microsoft.com/office/drawing/2014/main" id="{746EF5AE-AE9D-B6FC-EF36-BCCC20B822DF}"/>
               </a:ext>
             </a:extLst>
           </p:cNvPr>
@@ -1007,7 +1007,7 @@
           <p:cNvPr id="3" name="Text Placeholder 2">
             <a:extLst>
               <a:ext uri="{FF2B5EF4-FFF2-40B4-BE49-F238E27FC236}">
-                <a16:creationId xmlns:a16="http://schemas.microsoft.com/office/drawing/2014/main" id="{58AD6B24-E9B4-A696-4EF3-3B41DF75B28C}"/>
+                <a16:creationId xmlns:a16="http://schemas.microsoft.com/office/drawing/2014/main" id="{D1477929-4DC4-9213-BFC0-2BBDE2DBA145}"/>
               </a:ext>
             </a:extLst>
           </p:cNvPr>
@@ -1132,7 +1132,7 @@
           <p:cNvPr id="4" name="Date Placeholder 3">
             <a:extLst>
               <a:ext uri="{FF2B5EF4-FFF2-40B4-BE49-F238E27FC236}">
-                <a16:creationId xmlns:a16="http://schemas.microsoft.com/office/drawing/2014/main" id="{7BD2DD75-7F2B-488F-5183-5C01AAE074BC}"/>
+                <a16:creationId xmlns:a16="http://schemas.microsoft.com/office/drawing/2014/main" id="{0263753E-DB33-486A-C34F-9F9A5E07B37F}"/>
               </a:ext>
             </a:extLst>
           </p:cNvPr>
@@ -1148,9 +1148,9 @@
           <a:bodyPr/>
           <a:lstStyle/>
           <a:p>
-            <a:fld id="{B9C08E97-6EF3-448D-8F45-4AAD37A7D186}" type="datetimeFigureOut">
+            <a:fld id="{DDB4EC1F-5F29-4B45-A1E9-4711EF87C999}" type="datetimeFigureOut">
               <a:rPr lang="en-PH" smtClean="0"/>
-              <a:t>8/6/2026</a:t>
+              <a:t>8/7/2026</a:t>
             </a:fld>
             <a:endParaRPr lang="en-PH"/>
           </a:p>
@@ -1161,7 +1161,7 @@
           <p:cNvPr id="5" name="Footer Placeholder 4">
             <a:extLst>
               <a:ext uri="{FF2B5EF4-FFF2-40B4-BE49-F238E27FC236}">
-                <a16:creationId xmlns:a16="http://schemas.microsoft.com/office/drawing/2014/main" id="{A545388B-D599-A764-26FD-DF6F63E092AE}"/>
+                <a16:creationId xmlns:a16="http://schemas.microsoft.com/office/drawing/2014/main" id="{E1AD9E60-ABCA-8859-8DB3-E93138F5D2BC}"/>
               </a:ext>
             </a:extLst>
           </p:cNvPr>
@@ -1186,7 +1186,7 @@
           <p:cNvPr id="6" name="Slide Number Placeholder 5">
             <a:extLst>
               <a:ext uri="{FF2B5EF4-FFF2-40B4-BE49-F238E27FC236}">
-                <a16:creationId xmlns:a16="http://schemas.microsoft.com/office/drawing/2014/main" id="{E963DC8C-E3EC-80E0-5511-7E6F6A7F270C}"/>
+                <a16:creationId xmlns:a16="http://schemas.microsoft.com/office/drawing/2014/main" id="{E74A04C1-07AE-D7F2-A9CB-1A8864B03103}"/>
               </a:ext>
             </a:extLst>
           </p:cNvPr>
@@ -1202,7 +1202,7 @@
           <a:bodyPr/>
           <a:lstStyle/>
           <a:p>
-            <a:fld id="{B655F8A7-5DB9-4992-95EB-512B135CD058}" type="slidenum">
+            <a:fld id="{7FA8160B-192F-41E7-ADA4-0A7DED088FC5}" type="slidenum">
               <a:rPr lang="en-PH" smtClean="0"/>
               <a:t>‹#›</a:t>
             </a:fld>
@@ -1213,7 +1213,7 @@
     </p:spTree>
     <p:extLst>
       <p:ext uri="{BB962C8B-B14F-4D97-AF65-F5344CB8AC3E}">
-        <p14:creationId xmlns:p14="http://schemas.microsoft.com/office/powerpoint/2010/main" val="257196518"/>
+        <p14:creationId xmlns:p14="http://schemas.microsoft.com/office/powerpoint/2010/main" val="773815797"/>
       </p:ext>
     </p:extLst>
   </p:cSld>
@@ -1245,7 +1245,7 @@
           <p:cNvPr id="2" name="Title 1">
             <a:extLst>
               <a:ext uri="{FF2B5EF4-FFF2-40B4-BE49-F238E27FC236}">
-                <a16:creationId xmlns:a16="http://schemas.microsoft.com/office/drawing/2014/main" id="{B68D6CA3-7E02-EB68-FFD9-5D3B5C2D88A5}"/>
+                <a16:creationId xmlns:a16="http://schemas.microsoft.com/office/drawing/2014/main" id="{350FACB2-3D47-3334-5260-959F7C1BB85C}"/>
               </a:ext>
             </a:extLst>
           </p:cNvPr>
@@ -1274,7 +1274,7 @@
           <p:cNvPr id="3" name="Content Placeholder 2">
             <a:extLst>
               <a:ext uri="{FF2B5EF4-FFF2-40B4-BE49-F238E27FC236}">
-                <a16:creationId xmlns:a16="http://schemas.microsoft.com/office/drawing/2014/main" id="{17156555-9DA6-CCF9-7D44-541623439E38}"/>
+                <a16:creationId xmlns:a16="http://schemas.microsoft.com/office/drawing/2014/main" id="{DF4C26D0-50E8-F760-6F9A-571A196DAA78}"/>
               </a:ext>
             </a:extLst>
           </p:cNvPr>
@@ -1337,7 +1337,7 @@
           <p:cNvPr id="4" name="Content Placeholder 3">
             <a:extLst>
               <a:ext uri="{FF2B5EF4-FFF2-40B4-BE49-F238E27FC236}">
-                <a16:creationId xmlns:a16="http://schemas.microsoft.com/office/drawing/2014/main" id="{EAFECCEA-AE92-9FC0-2D7A-CEBEE19FFD73}"/>
+                <a16:creationId xmlns:a16="http://schemas.microsoft.com/office/drawing/2014/main" id="{769EC5E9-81A2-472A-303C-478A1D07B986}"/>
               </a:ext>
             </a:extLst>
           </p:cNvPr>
@@ -1400,7 +1400,7 @@
           <p:cNvPr id="5" name="Date Placeholder 4">
             <a:extLst>
               <a:ext uri="{FF2B5EF4-FFF2-40B4-BE49-F238E27FC236}">
-                <a16:creationId xmlns:a16="http://schemas.microsoft.com/office/drawing/2014/main" id="{FB092D6F-48C1-11C6-51EC-C4984EB3CEFF}"/>
+                <a16:creationId xmlns:a16="http://schemas.microsoft.com/office/drawing/2014/main" id="{2D9F156B-4265-12B1-E45F-4D3D19B769D8}"/>
               </a:ext>
             </a:extLst>
           </p:cNvPr>
@@ -1416,9 +1416,9 @@
           <a:bodyPr/>
           <a:lstStyle/>
           <a:p>
-            <a:fld id="{B9C08E97-6EF3-448D-8F45-4AAD37A7D186}" type="datetimeFigureOut">
+            <a:fld id="{DDB4EC1F-5F29-4B45-A1E9-4711EF87C999}" type="datetimeFigureOut">
               <a:rPr lang="en-PH" smtClean="0"/>
-              <a:t>8/6/2026</a:t>
+              <a:t>8/7/2026</a:t>
             </a:fld>
             <a:endParaRPr lang="en-PH"/>
           </a:p>
@@ -1429,7 +1429,7 @@
           <p:cNvPr id="6" name="Footer Placeholder 5">
             <a:extLst>
               <a:ext uri="{FF2B5EF4-FFF2-40B4-BE49-F238E27FC236}">
-                <a16:creationId xmlns:a16="http://schemas.microsoft.com/office/drawing/2014/main" id="{A3444067-F605-5EA7-9DEC-02BD6CB00D46}"/>
+                <a16:creationId xmlns:a16="http://schemas.microsoft.com/office/drawing/2014/main" id="{DCBF0022-A925-C5EE-DE8C-970FEC5DFC6B}"/>
               </a:ext>
             </a:extLst>
           </p:cNvPr>
@@ -1454,7 +1454,7 @@
           <p:cNvPr id="7" name="Slide Number Placeholder 6">
             <a:extLst>
               <a:ext uri="{FF2B5EF4-FFF2-40B4-BE49-F238E27FC236}">
-                <a16:creationId xmlns:a16="http://schemas.microsoft.com/office/drawing/2014/main" id="{891594E7-E723-CCC6-56BD-411CF233F7CA}"/>
+                <a16:creationId xmlns:a16="http://schemas.microsoft.com/office/drawing/2014/main" id="{BF307628-6846-56A3-14B7-433546F32B13}"/>
               </a:ext>
             </a:extLst>
           </p:cNvPr>
@@ -1470,7 +1470,7 @@
           <a:bodyPr/>
           <a:lstStyle/>
           <a:p>
-            <a:fld id="{B655F8A7-5DB9-4992-95EB-512B135CD058}" type="slidenum">
+            <a:fld id="{7FA8160B-192F-41E7-ADA4-0A7DED088FC5}" type="slidenum">
               <a:rPr lang="en-PH" smtClean="0"/>
               <a:t>‹#›</a:t>
             </a:fld>
@@ -1481,7 +1481,7 @@
     </p:spTree>
     <p:extLst>
       <p:ext uri="{BB962C8B-B14F-4D97-AF65-F5344CB8AC3E}">
-        <p14:creationId xmlns:p14="http://schemas.microsoft.com/office/powerpoint/2010/main" val="1199535458"/>
+        <p14:creationId xmlns:p14="http://schemas.microsoft.com/office/powerpoint/2010/main" val="3840025780"/>
       </p:ext>
     </p:extLst>
   </p:cSld>
@@ -1513,7 +1513,7 @@
           <p:cNvPr id="2" name="Title 1">
             <a:extLst>
               <a:ext uri="{FF2B5EF4-FFF2-40B4-BE49-F238E27FC236}">
-                <a16:creationId xmlns:a16="http://schemas.microsoft.com/office/drawing/2014/main" id="{182C5C47-4F88-4E7C-02C8-7B8521A58A3B}"/>
+                <a16:creationId xmlns:a16="http://schemas.microsoft.com/office/drawing/2014/main" id="{CD54E6CD-839C-93B7-E82A-716B1AF8BCC3}"/>
               </a:ext>
             </a:extLst>
           </p:cNvPr>
@@ -1547,7 +1547,7 @@
           <p:cNvPr id="3" name="Text Placeholder 2">
             <a:extLst>
               <a:ext uri="{FF2B5EF4-FFF2-40B4-BE49-F238E27FC236}">
-                <a16:creationId xmlns:a16="http://schemas.microsoft.com/office/drawing/2014/main" id="{37BF1339-DA73-09DD-B332-8A73EEB300EE}"/>
+                <a16:creationId xmlns:a16="http://schemas.microsoft.com/office/drawing/2014/main" id="{B4E7E4B8-923B-72FC-E467-5F4265564935}"/>
               </a:ext>
             </a:extLst>
           </p:cNvPr>
@@ -1618,7 +1618,7 @@
           <p:cNvPr id="4" name="Content Placeholder 3">
             <a:extLst>
               <a:ext uri="{FF2B5EF4-FFF2-40B4-BE49-F238E27FC236}">
-                <a16:creationId xmlns:a16="http://schemas.microsoft.com/office/drawing/2014/main" id="{2B849523-135F-A7F6-BADF-67FA151B1A86}"/>
+                <a16:creationId xmlns:a16="http://schemas.microsoft.com/office/drawing/2014/main" id="{051DEEEB-99CC-669D-ACF1-303EE64E5CF6}"/>
               </a:ext>
             </a:extLst>
           </p:cNvPr>
@@ -1681,7 +1681,7 @@
           <p:cNvPr id="5" name="Text Placeholder 4">
             <a:extLst>
               <a:ext uri="{FF2B5EF4-FFF2-40B4-BE49-F238E27FC236}">
-                <a16:creationId xmlns:a16="http://schemas.microsoft.com/office/drawing/2014/main" id="{722C5A64-5339-946F-C2F9-008F8BF582C4}"/>
+                <a16:creationId xmlns:a16="http://schemas.microsoft.com/office/drawing/2014/main" id="{85C24836-8EB7-0F58-A1F8-D75F5E03C3A5}"/>
               </a:ext>
             </a:extLst>
           </p:cNvPr>
@@ -1752,7 +1752,7 @@
           <p:cNvPr id="6" name="Content Placeholder 5">
             <a:extLst>
               <a:ext uri="{FF2B5EF4-FFF2-40B4-BE49-F238E27FC236}">
-                <a16:creationId xmlns:a16="http://schemas.microsoft.com/office/drawing/2014/main" id="{97DEE00E-4736-983B-1719-403B381C9C43}"/>
+                <a16:creationId xmlns:a16="http://schemas.microsoft.com/office/drawing/2014/main" id="{B0C71653-4072-38FF-BC8F-4CCC726DA91C}"/>
               </a:ext>
             </a:extLst>
           </p:cNvPr>
@@ -1815,7 +1815,7 @@
           <p:cNvPr id="7" name="Date Placeholder 6">
             <a:extLst>
               <a:ext uri="{FF2B5EF4-FFF2-40B4-BE49-F238E27FC236}">
-                <a16:creationId xmlns:a16="http://schemas.microsoft.com/office/drawing/2014/main" id="{2EA89D52-20AB-6FAE-18C4-1CBBEC368FC2}"/>
+                <a16:creationId xmlns:a16="http://schemas.microsoft.com/office/drawing/2014/main" id="{D7608349-8745-9C26-842E-A488BA94DFA1}"/>
               </a:ext>
             </a:extLst>
           </p:cNvPr>
@@ -1831,9 +1831,9 @@
           <a:bodyPr/>
           <a:lstStyle/>
           <a:p>
-            <a:fld id="{B9C08E97-6EF3-448D-8F45-4AAD37A7D186}" type="datetimeFigureOut">
+            <a:fld id="{DDB4EC1F-5F29-4B45-A1E9-4711EF87C999}" type="datetimeFigureOut">
               <a:rPr lang="en-PH" smtClean="0"/>
-              <a:t>8/6/2026</a:t>
+              <a:t>8/7/2026</a:t>
             </a:fld>
             <a:endParaRPr lang="en-PH"/>
           </a:p>
@@ -1844,7 +1844,7 @@
           <p:cNvPr id="8" name="Footer Placeholder 7">
             <a:extLst>
               <a:ext uri="{FF2B5EF4-FFF2-40B4-BE49-F238E27FC236}">
-                <a16:creationId xmlns:a16="http://schemas.microsoft.com/office/drawing/2014/main" id="{CAB2D001-F21C-D780-B32A-21E43D55CE94}"/>
+                <a16:creationId xmlns:a16="http://schemas.microsoft.com/office/drawing/2014/main" id="{FF793AFE-311A-D68D-2F00-EB019F9FAE95}"/>
               </a:ext>
             </a:extLst>
           </p:cNvPr>
@@ -1869,7 +1869,7 @@
           <p:cNvPr id="9" name="Slide Number Placeholder 8">
             <a:extLst>
               <a:ext uri="{FF2B5EF4-FFF2-40B4-BE49-F238E27FC236}">
-                <a16:creationId xmlns:a16="http://schemas.microsoft.com/office/drawing/2014/main" id="{B6719769-70EB-7516-4032-4BCE57555E0C}"/>
+                <a16:creationId xmlns:a16="http://schemas.microsoft.com/office/drawing/2014/main" id="{97649F3A-94DD-09EC-FD3F-C2644F9C9FAA}"/>
               </a:ext>
             </a:extLst>
           </p:cNvPr>
@@ -1885,7 +1885,7 @@
           <a:bodyPr/>
           <a:lstStyle/>
           <a:p>
-            <a:fld id="{B655F8A7-5DB9-4992-95EB-512B135CD058}" type="slidenum">
+            <a:fld id="{7FA8160B-192F-41E7-ADA4-0A7DED088FC5}" type="slidenum">
               <a:rPr lang="en-PH" smtClean="0"/>
               <a:t>‹#›</a:t>
             </a:fld>
@@ -1896,7 +1896,7 @@
     </p:spTree>
     <p:extLst>
       <p:ext uri="{BB962C8B-B14F-4D97-AF65-F5344CB8AC3E}">
-        <p14:creationId xmlns:p14="http://schemas.microsoft.com/office/powerpoint/2010/main" val="1116876167"/>
+        <p14:creationId xmlns:p14="http://schemas.microsoft.com/office/powerpoint/2010/main" val="4160830860"/>
       </p:ext>
     </p:extLst>
   </p:cSld>
@@ -1928,7 +1928,7 @@
           <p:cNvPr id="2" name="Title 1">
             <a:extLst>
               <a:ext uri="{FF2B5EF4-FFF2-40B4-BE49-F238E27FC236}">
-                <a16:creationId xmlns:a16="http://schemas.microsoft.com/office/drawing/2014/main" id="{2322D1BB-6FF0-5B2B-2EA3-972DE45B2DB6}"/>
+                <a16:creationId xmlns:a16="http://schemas.microsoft.com/office/drawing/2014/main" id="{C358F697-8DBC-1EE1-ED6C-4FF56C65F24D}"/>
               </a:ext>
             </a:extLst>
           </p:cNvPr>
@@ -1957,7 +1957,7 @@
           <p:cNvPr id="3" name="Date Placeholder 2">
             <a:extLst>
               <a:ext uri="{FF2B5EF4-FFF2-40B4-BE49-F238E27FC236}">
-                <a16:creationId xmlns:a16="http://schemas.microsoft.com/office/drawing/2014/main" id="{FE6E1906-915E-194A-3120-42A903F6B6E9}"/>
+                <a16:creationId xmlns:a16="http://schemas.microsoft.com/office/drawing/2014/main" id="{36048FF5-33F3-E7E4-ED09-AC74881DF767}"/>
               </a:ext>
             </a:extLst>
           </p:cNvPr>
@@ -1973,9 +1973,9 @@
           <a:bodyPr/>
           <a:lstStyle/>
           <a:p>
-            <a:fld id="{B9C08E97-6EF3-448D-8F45-4AAD37A7D186}" type="datetimeFigureOut">
+            <a:fld id="{DDB4EC1F-5F29-4B45-A1E9-4711EF87C999}" type="datetimeFigureOut">
               <a:rPr lang="en-PH" smtClean="0"/>
-              <a:t>8/6/2026</a:t>
+              <a:t>8/7/2026</a:t>
             </a:fld>
             <a:endParaRPr lang="en-PH"/>
           </a:p>
@@ -1986,7 +1986,7 @@
           <p:cNvPr id="4" name="Footer Placeholder 3">
             <a:extLst>
               <a:ext uri="{FF2B5EF4-FFF2-40B4-BE49-F238E27FC236}">
-                <a16:creationId xmlns:a16="http://schemas.microsoft.com/office/drawing/2014/main" id="{FEF195FE-8A47-D49C-389C-371FD208D823}"/>
+                <a16:creationId xmlns:a16="http://schemas.microsoft.com/office/drawing/2014/main" id="{EED8C468-49DA-F9C4-5ABF-7DB44EA4475E}"/>
               </a:ext>
             </a:extLst>
           </p:cNvPr>
@@ -2011,7 +2011,7 @@
           <p:cNvPr id="5" name="Slide Number Placeholder 4">
             <a:extLst>
               <a:ext uri="{FF2B5EF4-FFF2-40B4-BE49-F238E27FC236}">
-                <a16:creationId xmlns:a16="http://schemas.microsoft.com/office/drawing/2014/main" id="{46ACF06F-0D09-880D-6C0F-601110819AB9}"/>
+                <a16:creationId xmlns:a16="http://schemas.microsoft.com/office/drawing/2014/main" id="{88FD1C45-B290-F9E3-12B9-11767E40105E}"/>
               </a:ext>
             </a:extLst>
           </p:cNvPr>
@@ -2027,7 +2027,7 @@
           <a:bodyPr/>
           <a:lstStyle/>
           <a:p>
-            <a:fld id="{B655F8A7-5DB9-4992-95EB-512B135CD058}" type="slidenum">
+            <a:fld id="{7FA8160B-192F-41E7-ADA4-0A7DED088FC5}" type="slidenum">
               <a:rPr lang="en-PH" smtClean="0"/>
               <a:t>‹#›</a:t>
             </a:fld>
@@ -2038,7 +2038,7 @@
     </p:spTree>
     <p:extLst>
       <p:ext uri="{BB962C8B-B14F-4D97-AF65-F5344CB8AC3E}">
-        <p14:creationId xmlns:p14="http://schemas.microsoft.com/office/powerpoint/2010/main" val="3044319255"/>
+        <p14:creationId xmlns:p14="http://schemas.microsoft.com/office/powerpoint/2010/main" val="3469947636"/>
       </p:ext>
     </p:extLst>
   </p:cSld>
@@ -2070,7 +2070,7 @@
           <p:cNvPr id="2" name="Date Placeholder 1">
             <a:extLst>
               <a:ext uri="{FF2B5EF4-FFF2-40B4-BE49-F238E27FC236}">
-                <a16:creationId xmlns:a16="http://schemas.microsoft.com/office/drawing/2014/main" id="{94CEFEFE-3035-B7B3-0BFB-0CED7E9B65C8}"/>
+                <a16:creationId xmlns:a16="http://schemas.microsoft.com/office/drawing/2014/main" id="{19C1156A-F2A9-3097-CEE0-4EA0E8905798}"/>
               </a:ext>
             </a:extLst>
           </p:cNvPr>
@@ -2086,9 +2086,9 @@
           <a:bodyPr/>
           <a:lstStyle/>
           <a:p>
-            <a:fld id="{B9C08E97-6EF3-448D-8F45-4AAD37A7D186}" type="datetimeFigureOut">
+            <a:fld id="{DDB4EC1F-5F29-4B45-A1E9-4711EF87C999}" type="datetimeFigureOut">
               <a:rPr lang="en-PH" smtClean="0"/>
-              <a:t>8/6/2026</a:t>
+              <a:t>8/7/2026</a:t>
             </a:fld>
             <a:endParaRPr lang="en-PH"/>
           </a:p>
@@ -2099,7 +2099,7 @@
           <p:cNvPr id="3" name="Footer Placeholder 2">
             <a:extLst>
               <a:ext uri="{FF2B5EF4-FFF2-40B4-BE49-F238E27FC236}">
-                <a16:creationId xmlns:a16="http://schemas.microsoft.com/office/drawing/2014/main" id="{8E0BC8A7-4A52-D052-100B-D671EE0ABAE0}"/>
+                <a16:creationId xmlns:a16="http://schemas.microsoft.com/office/drawing/2014/main" id="{C5CCCECB-DD7D-BEAB-86C1-B86946C0CD1D}"/>
               </a:ext>
             </a:extLst>
           </p:cNvPr>
@@ -2124,7 +2124,7 @@
           <p:cNvPr id="4" name="Slide Number Placeholder 3">
             <a:extLst>
               <a:ext uri="{FF2B5EF4-FFF2-40B4-BE49-F238E27FC236}">
-                <a16:creationId xmlns:a16="http://schemas.microsoft.com/office/drawing/2014/main" id="{2588076E-B60D-B79E-15F7-DB04A4CF71BE}"/>
+                <a16:creationId xmlns:a16="http://schemas.microsoft.com/office/drawing/2014/main" id="{1EF2966B-5333-3AFA-4967-CB598B0592E5}"/>
               </a:ext>
             </a:extLst>
           </p:cNvPr>
@@ -2140,7 +2140,7 @@
           <a:bodyPr/>
           <a:lstStyle/>
           <a:p>
-            <a:fld id="{B655F8A7-5DB9-4992-95EB-512B135CD058}" type="slidenum">
+            <a:fld id="{7FA8160B-192F-41E7-ADA4-0A7DED088FC5}" type="slidenum">
               <a:rPr lang="en-PH" smtClean="0"/>
               <a:t>‹#›</a:t>
             </a:fld>
@@ -2151,7 +2151,7 @@
     </p:spTree>
     <p:extLst>
       <p:ext uri="{BB962C8B-B14F-4D97-AF65-F5344CB8AC3E}">
-        <p14:creationId xmlns:p14="http://schemas.microsoft.com/office/powerpoint/2010/main" val="1941260222"/>
+        <p14:creationId xmlns:p14="http://schemas.microsoft.com/office/powerpoint/2010/main" val="1091179079"/>
       </p:ext>
     </p:extLst>
   </p:cSld>
@@ -2183,7 +2183,7 @@
           <p:cNvPr id="2" name="Title 1">
             <a:extLst>
               <a:ext uri="{FF2B5EF4-FFF2-40B4-BE49-F238E27FC236}">
-                <a16:creationId xmlns:a16="http://schemas.microsoft.com/office/drawing/2014/main" id="{BDF7DB81-9B63-0DA0-5C40-37803E3BD633}"/>
+                <a16:creationId xmlns:a16="http://schemas.microsoft.com/office/drawing/2014/main" id="{4CC002A0-3A8A-C2FB-8CFE-0F3F685FBFF5}"/>
               </a:ext>
             </a:extLst>
           </p:cNvPr>
@@ -2221,7 +2221,7 @@
           <p:cNvPr id="3" name="Content Placeholder 2">
             <a:extLst>
               <a:ext uri="{FF2B5EF4-FFF2-40B4-BE49-F238E27FC236}">
-                <a16:creationId xmlns:a16="http://schemas.microsoft.com/office/drawing/2014/main" id="{64B99606-B345-BA9F-5FFB-5A27B3EFA0F9}"/>
+                <a16:creationId xmlns:a16="http://schemas.microsoft.com/office/drawing/2014/main" id="{520C220A-07D4-75EF-2F10-566A5502997C}"/>
               </a:ext>
             </a:extLst>
           </p:cNvPr>
@@ -2312,7 +2312,7 @@
           <p:cNvPr id="4" name="Text Placeholder 3">
             <a:extLst>
               <a:ext uri="{FF2B5EF4-FFF2-40B4-BE49-F238E27FC236}">
-                <a16:creationId xmlns:a16="http://schemas.microsoft.com/office/drawing/2014/main" id="{1B5C8B6C-3C09-C485-5C17-98DAA7A66EBD}"/>
+                <a16:creationId xmlns:a16="http://schemas.microsoft.com/office/drawing/2014/main" id="{452DA65B-C1DF-22FF-8268-26A4AAE5A36A}"/>
               </a:ext>
             </a:extLst>
           </p:cNvPr>
@@ -2383,7 +2383,7 @@
           <p:cNvPr id="5" name="Date Placeholder 4">
             <a:extLst>
               <a:ext uri="{FF2B5EF4-FFF2-40B4-BE49-F238E27FC236}">
-                <a16:creationId xmlns:a16="http://schemas.microsoft.com/office/drawing/2014/main" id="{31B6E4B8-23DB-3E4D-E1E2-4B6C23DAC4A7}"/>
+                <a16:creationId xmlns:a16="http://schemas.microsoft.com/office/drawing/2014/main" id="{78C05941-94C6-F9C0-EDA4-4A6900E5A9AB}"/>
               </a:ext>
             </a:extLst>
           </p:cNvPr>
@@ -2399,9 +2399,9 @@
           <a:bodyPr/>
           <a:lstStyle/>
           <a:p>
-            <a:fld id="{B9C08E97-6EF3-448D-8F45-4AAD37A7D186}" type="datetimeFigureOut">
+            <a:fld id="{DDB4EC1F-5F29-4B45-A1E9-4711EF87C999}" type="datetimeFigureOut">
               <a:rPr lang="en-PH" smtClean="0"/>
-              <a:t>8/6/2026</a:t>
+              <a:t>8/7/2026</a:t>
             </a:fld>
             <a:endParaRPr lang="en-PH"/>
           </a:p>
@@ -2412,7 +2412,7 @@
           <p:cNvPr id="6" name="Footer Placeholder 5">
             <a:extLst>
               <a:ext uri="{FF2B5EF4-FFF2-40B4-BE49-F238E27FC236}">
-                <a16:creationId xmlns:a16="http://schemas.microsoft.com/office/drawing/2014/main" id="{4992D8C7-F5A4-2388-98D3-6773677BB404}"/>
+                <a16:creationId xmlns:a16="http://schemas.microsoft.com/office/drawing/2014/main" id="{9CC9E48A-F917-05F8-CE08-A98B8FAD85B6}"/>
               </a:ext>
             </a:extLst>
           </p:cNvPr>
@@ -2437,7 +2437,7 @@
           <p:cNvPr id="7" name="Slide Number Placeholder 6">
             <a:extLst>
               <a:ext uri="{FF2B5EF4-FFF2-40B4-BE49-F238E27FC236}">
-                <a16:creationId xmlns:a16="http://schemas.microsoft.com/office/drawing/2014/main" id="{E551FDF9-B628-F70F-B61D-D4C18E3CC05C}"/>
+                <a16:creationId xmlns:a16="http://schemas.microsoft.com/office/drawing/2014/main" id="{11B5074A-7F29-041B-2E3E-AD912D96B3CC}"/>
               </a:ext>
             </a:extLst>
           </p:cNvPr>
@@ -2453,7 +2453,7 @@
           <a:bodyPr/>
           <a:lstStyle/>
           <a:p>
-            <a:fld id="{B655F8A7-5DB9-4992-95EB-512B135CD058}" type="slidenum">
+            <a:fld id="{7FA8160B-192F-41E7-ADA4-0A7DED088FC5}" type="slidenum">
               <a:rPr lang="en-PH" smtClean="0"/>
               <a:t>‹#›</a:t>
             </a:fld>
@@ -2464,7 +2464,7 @@
     </p:spTree>
     <p:extLst>
       <p:ext uri="{BB962C8B-B14F-4D97-AF65-F5344CB8AC3E}">
-        <p14:creationId xmlns:p14="http://schemas.microsoft.com/office/powerpoint/2010/main" val="1660052072"/>
+        <p14:creationId xmlns:p14="http://schemas.microsoft.com/office/powerpoint/2010/main" val="188925295"/>
       </p:ext>
     </p:extLst>
   </p:cSld>
@@ -2496,7 +2496,7 @@
           <p:cNvPr id="2" name="Title 1">
             <a:extLst>
               <a:ext uri="{FF2B5EF4-FFF2-40B4-BE49-F238E27FC236}">
-                <a16:creationId xmlns:a16="http://schemas.microsoft.com/office/drawing/2014/main" id="{3E69E6C1-627F-F4CB-72BC-BBFA6B2EB5AE}"/>
+                <a16:creationId xmlns:a16="http://schemas.microsoft.com/office/drawing/2014/main" id="{5395789E-3789-1096-EF56-67E60B36AD5D}"/>
               </a:ext>
             </a:extLst>
           </p:cNvPr>
@@ -2534,7 +2534,7 @@
           <p:cNvPr id="3" name="Picture Placeholder 2">
             <a:extLst>
               <a:ext uri="{FF2B5EF4-FFF2-40B4-BE49-F238E27FC236}">
-                <a16:creationId xmlns:a16="http://schemas.microsoft.com/office/drawing/2014/main" id="{14146F9B-EEBC-EC85-3D3D-20D63672263E}"/>
+                <a16:creationId xmlns:a16="http://schemas.microsoft.com/office/drawing/2014/main" id="{1D462D0B-2A94-8237-1EB9-916144842972}"/>
               </a:ext>
             </a:extLst>
           </p:cNvPr>
@@ -2601,7 +2601,7 @@
           <p:cNvPr id="4" name="Text Placeholder 3">
             <a:extLst>
               <a:ext uri="{FF2B5EF4-FFF2-40B4-BE49-F238E27FC236}">
-                <a16:creationId xmlns:a16="http://schemas.microsoft.com/office/drawing/2014/main" id="{97E7797F-0FB8-D1C9-7F89-338F1EF15A5C}"/>
+                <a16:creationId xmlns:a16="http://schemas.microsoft.com/office/drawing/2014/main" id="{A2A469E3-2F0F-0D8E-F5CE-9A28108CFFEF}"/>
               </a:ext>
             </a:extLst>
           </p:cNvPr>
@@ -2672,7 +2672,7 @@
           <p:cNvPr id="5" name="Date Placeholder 4">
             <a:extLst>
               <a:ext uri="{FF2B5EF4-FFF2-40B4-BE49-F238E27FC236}">
-                <a16:creationId xmlns:a16="http://schemas.microsoft.com/office/drawing/2014/main" id="{28E98192-1088-56F2-BC12-5D545BAE3249}"/>
+                <a16:creationId xmlns:a16="http://schemas.microsoft.com/office/drawing/2014/main" id="{CB0BBFF8-0635-6B98-7F19-3898E9D6AC72}"/>
               </a:ext>
             </a:extLst>
           </p:cNvPr>
@@ -2688,9 +2688,9 @@
           <a:bodyPr/>
           <a:lstStyle/>
           <a:p>
-            <a:fld id="{B9C08E97-6EF3-448D-8F45-4AAD37A7D186}" type="datetimeFigureOut">
+            <a:fld id="{DDB4EC1F-5F29-4B45-A1E9-4711EF87C999}" type="datetimeFigureOut">
               <a:rPr lang="en-PH" smtClean="0"/>
-              <a:t>8/6/2026</a:t>
+              <a:t>8/7/2026</a:t>
             </a:fld>
             <a:endParaRPr lang="en-PH"/>
           </a:p>
@@ -2701,7 +2701,7 @@
           <p:cNvPr id="6" name="Footer Placeholder 5">
             <a:extLst>
               <a:ext uri="{FF2B5EF4-FFF2-40B4-BE49-F238E27FC236}">
-                <a16:creationId xmlns:a16="http://schemas.microsoft.com/office/drawing/2014/main" id="{B1478094-23A3-7039-DBC3-D4F6003F7CC7}"/>
+                <a16:creationId xmlns:a16="http://schemas.microsoft.com/office/drawing/2014/main" id="{96023231-C70E-DED0-D66F-1D6BC78AE82B}"/>
               </a:ext>
             </a:extLst>
           </p:cNvPr>
@@ -2726,7 +2726,7 @@
           <p:cNvPr id="7" name="Slide Number Placeholder 6">
             <a:extLst>
               <a:ext uri="{FF2B5EF4-FFF2-40B4-BE49-F238E27FC236}">
-                <a16:creationId xmlns:a16="http://schemas.microsoft.com/office/drawing/2014/main" id="{DC9EA05C-4A15-C7D7-8200-3E78DCF76E18}"/>
+                <a16:creationId xmlns:a16="http://schemas.microsoft.com/office/drawing/2014/main" id="{D25DB474-637B-4421-0AC0-A02379F4C2CB}"/>
               </a:ext>
             </a:extLst>
           </p:cNvPr>
@@ -2742,7 +2742,7 @@
           <a:bodyPr/>
           <a:lstStyle/>
           <a:p>
-            <a:fld id="{B655F8A7-5DB9-4992-95EB-512B135CD058}" type="slidenum">
+            <a:fld id="{7FA8160B-192F-41E7-ADA4-0A7DED088FC5}" type="slidenum">
               <a:rPr lang="en-PH" smtClean="0"/>
               <a:t>‹#›</a:t>
             </a:fld>
@@ -2753,7 +2753,7 @@
     </p:spTree>
     <p:extLst>
       <p:ext uri="{BB962C8B-B14F-4D97-AF65-F5344CB8AC3E}">
-        <p14:creationId xmlns:p14="http://schemas.microsoft.com/office/powerpoint/2010/main" val="799970653"/>
+        <p14:creationId xmlns:p14="http://schemas.microsoft.com/office/powerpoint/2010/main" val="876983409"/>
       </p:ext>
     </p:extLst>
   </p:cSld>
@@ -2790,7 +2790,7 @@
           <p:cNvPr id="2" name="Title Placeholder 1">
             <a:extLst>
               <a:ext uri="{FF2B5EF4-FFF2-40B4-BE49-F238E27FC236}">
-                <a16:creationId xmlns:a16="http://schemas.microsoft.com/office/drawing/2014/main" id="{8FFA200C-CFC0-18FD-A57E-DE10A56193E2}"/>
+                <a16:creationId xmlns:a16="http://schemas.microsoft.com/office/drawing/2014/main" id="{439945B4-D84A-88C8-056C-34A4FB304D59}"/>
               </a:ext>
             </a:extLst>
           </p:cNvPr>
@@ -2829,7 +2829,7 @@
           <p:cNvPr id="3" name="Text Placeholder 2">
             <a:extLst>
               <a:ext uri="{FF2B5EF4-FFF2-40B4-BE49-F238E27FC236}">
-                <a16:creationId xmlns:a16="http://schemas.microsoft.com/office/drawing/2014/main" id="{1A2C0286-D5B6-1A2A-EB67-596EB1CB2D44}"/>
+                <a16:creationId xmlns:a16="http://schemas.microsoft.com/office/drawing/2014/main" id="{B84D6B1A-2C55-C6E6-F7AF-1B33CB791E17}"/>
               </a:ext>
             </a:extLst>
           </p:cNvPr>
@@ -2897,7 +2897,7 @@
           <p:cNvPr id="4" name="Date Placeholder 3">
             <a:extLst>
               <a:ext uri="{FF2B5EF4-FFF2-40B4-BE49-F238E27FC236}">
-                <a16:creationId xmlns:a16="http://schemas.microsoft.com/office/drawing/2014/main" id="{A4FC3A23-C8F8-0355-3746-26A6B1044056}"/>
+                <a16:creationId xmlns:a16="http://schemas.microsoft.com/office/drawing/2014/main" id="{E7D2AA95-E9DB-43DD-6A3E-AF505F43F415}"/>
               </a:ext>
             </a:extLst>
           </p:cNvPr>
@@ -2931,9 +2931,9 @@
             </a:lvl1pPr>
           </a:lstStyle>
           <a:p>
-            <a:fld id="{B9C08E97-6EF3-448D-8F45-4AAD37A7D186}" type="datetimeFigureOut">
+            <a:fld id="{DDB4EC1F-5F29-4B45-A1E9-4711EF87C999}" type="datetimeFigureOut">
               <a:rPr lang="en-PH" smtClean="0"/>
-              <a:t>8/6/2026</a:t>
+              <a:t>8/7/2026</a:t>
             </a:fld>
             <a:endParaRPr lang="en-PH"/>
           </a:p>
@@ -2944,7 +2944,7 @@
           <p:cNvPr id="5" name="Footer Placeholder 4">
             <a:extLst>
               <a:ext uri="{FF2B5EF4-FFF2-40B4-BE49-F238E27FC236}">
-                <a16:creationId xmlns:a16="http://schemas.microsoft.com/office/drawing/2014/main" id="{37A51BCB-DB02-8186-0E3E-620BB0933EBF}"/>
+                <a16:creationId xmlns:a16="http://schemas.microsoft.com/office/drawing/2014/main" id="{6DC4BE71-F7E7-2841-2674-177DF136252B}"/>
               </a:ext>
             </a:extLst>
           </p:cNvPr>
@@ -2987,7 +2987,7 @@
           <p:cNvPr id="6" name="Slide Number Placeholder 5">
             <a:extLst>
               <a:ext uri="{FF2B5EF4-FFF2-40B4-BE49-F238E27FC236}">
-                <a16:creationId xmlns:a16="http://schemas.microsoft.com/office/drawing/2014/main" id="{B49EE6BA-7B73-2654-B262-77CB760748CE}"/>
+                <a16:creationId xmlns:a16="http://schemas.microsoft.com/office/drawing/2014/main" id="{D711CDFC-5D39-EF4A-6D72-F3D75CECDAF9}"/>
               </a:ext>
             </a:extLst>
           </p:cNvPr>
@@ -3021,7 +3021,7 @@
             </a:lvl1pPr>
           </a:lstStyle>
           <a:p>
-            <a:fld id="{B655F8A7-5DB9-4992-95EB-512B135CD058}" type="slidenum">
+            <a:fld id="{7FA8160B-192F-41E7-ADA4-0A7DED088FC5}" type="slidenum">
               <a:rPr lang="en-PH" smtClean="0"/>
               <a:t>‹#›</a:t>
             </a:fld>
@@ -3032,7 +3032,7 @@
     </p:spTree>
     <p:extLst>
       <p:ext uri="{BB962C8B-B14F-4D97-AF65-F5344CB8AC3E}">
-        <p14:creationId xmlns:p14="http://schemas.microsoft.com/office/powerpoint/2010/main" val="2492540562"/>
+        <p14:creationId xmlns:p14="http://schemas.microsoft.com/office/powerpoint/2010/main" val="520179680"/>
       </p:ext>
     </p:extLst>
   </p:cSld>
@@ -3363,7 +3363,7 @@
           <p:cNvPr id="2" name="TextBox 1">
             <a:extLst>
               <a:ext uri="{FF2B5EF4-FFF2-40B4-BE49-F238E27FC236}">
-                <a16:creationId xmlns:a16="http://schemas.microsoft.com/office/drawing/2014/main" id="{7EB02B12-377B-DD33-7AB0-F0D8247AA4D1}"/>
+                <a16:creationId xmlns:a16="http://schemas.microsoft.com/office/drawing/2014/main" id="{1CC71C6F-324A-576E-9DD2-9E4D39A84F6E}"/>
               </a:ext>
             </a:extLst>
           </p:cNvPr>
@@ -3403,7 +3403,7 @@
           <p:cNvPr id="3" name="TextBox 2">
             <a:extLst>
               <a:ext uri="{FF2B5EF4-FFF2-40B4-BE49-F238E27FC236}">
-                <a16:creationId xmlns:a16="http://schemas.microsoft.com/office/drawing/2014/main" id="{0628D1E6-DD1C-5AC7-AE4E-2F1DB19B40EA}"/>
+                <a16:creationId xmlns:a16="http://schemas.microsoft.com/office/drawing/2014/main" id="{32484DCA-F88B-DC4E-3AE4-68847DFFA3DB}"/>
               </a:ext>
             </a:extLst>
           </p:cNvPr>
@@ -3460,7 +3460,7 @@
           <p:cNvPr id="4" name="Straight Connector 3">
             <a:extLst>
               <a:ext uri="{FF2B5EF4-FFF2-40B4-BE49-F238E27FC236}">
-                <a16:creationId xmlns:a16="http://schemas.microsoft.com/office/drawing/2014/main" id="{D1F01CC5-07B9-ACF0-5E5E-BEC217505F67}"/>
+                <a16:creationId xmlns:a16="http://schemas.microsoft.com/office/drawing/2014/main" id="{DABF8F18-AA9D-243E-FB46-0013CD96A15C}"/>
               </a:ext>
             </a:extLst>
           </p:cNvPr>
@@ -3501,7 +3501,7 @@
           <p:cNvPr id="5" name="TextBox 4">
             <a:extLst>
               <a:ext uri="{FF2B5EF4-FFF2-40B4-BE49-F238E27FC236}">
-                <a16:creationId xmlns:a16="http://schemas.microsoft.com/office/drawing/2014/main" id="{8C959BDB-945D-E5B5-4DFA-C70E767538D0}"/>
+                <a16:creationId xmlns:a16="http://schemas.microsoft.com/office/drawing/2014/main" id="{96A445E5-54D4-5B6F-6B96-9BCBEFA2CF2D}"/>
               </a:ext>
             </a:extLst>
           </p:cNvPr>
@@ -3547,7 +3547,7 @@
           <p:cNvPr id="6" name="TextBox 5">
             <a:extLst>
               <a:ext uri="{FF2B5EF4-FFF2-40B4-BE49-F238E27FC236}">
-                <a16:creationId xmlns:a16="http://schemas.microsoft.com/office/drawing/2014/main" id="{7CC1F089-5EF6-41FC-E07E-E4E57A6ABB1E}"/>
+                <a16:creationId xmlns:a16="http://schemas.microsoft.com/office/drawing/2014/main" id="{C01671D2-2920-D07A-985D-7BEA689585DF}"/>
               </a:ext>
             </a:extLst>
           </p:cNvPr>
@@ -3591,7 +3591,7 @@
     </p:spTree>
     <p:extLst>
       <p:ext uri="{BB962C8B-B14F-4D97-AF65-F5344CB8AC3E}">
-        <p14:creationId xmlns:p14="http://schemas.microsoft.com/office/powerpoint/2010/main" val="1176606609"/>
+        <p14:creationId xmlns:p14="http://schemas.microsoft.com/office/powerpoint/2010/main" val="822972590"/>
       </p:ext>
     </p:extLst>
   </p:cSld>
@@ -3631,7 +3631,7 @@
           <p:cNvPr id="2" name="TextBox 1">
             <a:extLst>
               <a:ext uri="{FF2B5EF4-FFF2-40B4-BE49-F238E27FC236}">
-                <a16:creationId xmlns:a16="http://schemas.microsoft.com/office/drawing/2014/main" id="{429B776D-D6B3-E1C3-BB99-9A66CA746A96}"/>
+                <a16:creationId xmlns:a16="http://schemas.microsoft.com/office/drawing/2014/main" id="{C6EBD7B8-CEAF-532A-59C7-F35C0C11D12C}"/>
               </a:ext>
             </a:extLst>
           </p:cNvPr>
@@ -3671,7 +3671,7 @@
           <p:cNvPr id="3" name="TextBox 2">
             <a:extLst>
               <a:ext uri="{FF2B5EF4-FFF2-40B4-BE49-F238E27FC236}">
-                <a16:creationId xmlns:a16="http://schemas.microsoft.com/office/drawing/2014/main" id="{F0ED694F-AF8C-B84B-0E8E-5FED7F5E3856}"/>
+                <a16:creationId xmlns:a16="http://schemas.microsoft.com/office/drawing/2014/main" id="{49DF0DF3-D913-348F-076D-20C130576D5E}"/>
               </a:ext>
             </a:extLst>
           </p:cNvPr>
@@ -3717,7 +3717,7 @@
           <p:cNvPr id="4" name="Straight Connector 3">
             <a:extLst>
               <a:ext uri="{FF2B5EF4-FFF2-40B4-BE49-F238E27FC236}">
-                <a16:creationId xmlns:a16="http://schemas.microsoft.com/office/drawing/2014/main" id="{20BF612F-E58D-606F-F353-0EDA59EE6772}"/>
+                <a16:creationId xmlns:a16="http://schemas.microsoft.com/office/drawing/2014/main" id="{814B033F-DF32-C95B-8E14-E95CA1122516}"/>
               </a:ext>
             </a:extLst>
           </p:cNvPr>
@@ -3758,7 +3758,7 @@
           <p:cNvPr id="5" name="TextBox 4">
             <a:extLst>
               <a:ext uri="{FF2B5EF4-FFF2-40B4-BE49-F238E27FC236}">
-                <a16:creationId xmlns:a16="http://schemas.microsoft.com/office/drawing/2014/main" id="{700AD815-5847-2303-740E-A6E8C8A0985C}"/>
+                <a16:creationId xmlns:a16="http://schemas.microsoft.com/office/drawing/2014/main" id="{35C2096B-C34D-CACE-DE76-DC9C77AAE477}"/>
               </a:ext>
             </a:extLst>
           </p:cNvPr>
@@ -3869,7 +3869,7 @@
           <p:cNvPr id="6" name="Rectangle: Rounded Corners 5">
             <a:extLst>
               <a:ext uri="{FF2B5EF4-FFF2-40B4-BE49-F238E27FC236}">
-                <a16:creationId xmlns:a16="http://schemas.microsoft.com/office/drawing/2014/main" id="{46A33524-FB1A-446A-A4C3-09994C5CC1C2}"/>
+                <a16:creationId xmlns:a16="http://schemas.microsoft.com/office/drawing/2014/main" id="{801B58CA-DFA2-B69F-617C-CD34B8291072}"/>
               </a:ext>
             </a:extLst>
           </p:cNvPr>
@@ -3925,7 +3925,7 @@
           <p:cNvPr id="7" name="TextBox 6">
             <a:extLst>
               <a:ext uri="{FF2B5EF4-FFF2-40B4-BE49-F238E27FC236}">
-                <a16:creationId xmlns:a16="http://schemas.microsoft.com/office/drawing/2014/main" id="{00425E9E-FF7C-C406-31A8-C860180EC241}"/>
+                <a16:creationId xmlns:a16="http://schemas.microsoft.com/office/drawing/2014/main" id="{009A096E-637F-F3B6-EC6F-B82F44965841}"/>
               </a:ext>
             </a:extLst>
           </p:cNvPr>
@@ -3971,7 +3971,7 @@
           <p:cNvPr id="8" name="TextBox 7">
             <a:extLst>
               <a:ext uri="{FF2B5EF4-FFF2-40B4-BE49-F238E27FC236}">
-                <a16:creationId xmlns:a16="http://schemas.microsoft.com/office/drawing/2014/main" id="{C768969A-D33C-2E4D-8654-AAE383BB51A4}"/>
+                <a16:creationId xmlns:a16="http://schemas.microsoft.com/office/drawing/2014/main" id="{931ED967-13CE-075E-1383-B2DA62C1153E}"/>
               </a:ext>
             </a:extLst>
           </p:cNvPr>
@@ -4036,7 +4036,7 @@
           <p:cNvPr id="9" name="TextBox 8">
             <a:extLst>
               <a:ext uri="{FF2B5EF4-FFF2-40B4-BE49-F238E27FC236}">
-                <a16:creationId xmlns:a16="http://schemas.microsoft.com/office/drawing/2014/main" id="{D60054F2-5F05-C96F-85E2-F5D71D33BA92}"/>
+                <a16:creationId xmlns:a16="http://schemas.microsoft.com/office/drawing/2014/main" id="{33FF3054-9A26-0519-058A-0AACDE52E906}"/>
               </a:ext>
             </a:extLst>
           </p:cNvPr>
@@ -4082,7 +4082,7 @@
           <p:cNvPr id="10" name="TextBox 9">
             <a:extLst>
               <a:ext uri="{FF2B5EF4-FFF2-40B4-BE49-F238E27FC236}">
-                <a16:creationId xmlns:a16="http://schemas.microsoft.com/office/drawing/2014/main" id="{36B31966-0885-BEC4-F16A-E8A07EF625D4}"/>
+                <a16:creationId xmlns:a16="http://schemas.microsoft.com/office/drawing/2014/main" id="{05C90915-1DDC-325A-7549-D37BF4421DA9}"/>
               </a:ext>
             </a:extLst>
           </p:cNvPr>
@@ -4120,7 +4120,7 @@
     </p:spTree>
     <p:extLst>
       <p:ext uri="{BB962C8B-B14F-4D97-AF65-F5344CB8AC3E}">
-        <p14:creationId xmlns:p14="http://schemas.microsoft.com/office/powerpoint/2010/main" val="1861754141"/>
+        <p14:creationId xmlns:p14="http://schemas.microsoft.com/office/powerpoint/2010/main" val="3159118357"/>
       </p:ext>
     </p:extLst>
   </p:cSld>
@@ -4160,7 +4160,7 @@
           <p:cNvPr id="2" name="TextBox 1">
             <a:extLst>
               <a:ext uri="{FF2B5EF4-FFF2-40B4-BE49-F238E27FC236}">
-                <a16:creationId xmlns:a16="http://schemas.microsoft.com/office/drawing/2014/main" id="{AFF05A54-9C9C-0DC6-94BC-BDA4D7D6D8B0}"/>
+                <a16:creationId xmlns:a16="http://schemas.microsoft.com/office/drawing/2014/main" id="{9300A13A-2AC7-2A82-EF44-904508439EB9}"/>
               </a:ext>
             </a:extLst>
           </p:cNvPr>
@@ -4206,7 +4206,7 @@
           <p:cNvPr id="3" name="TextBox 2">
             <a:extLst>
               <a:ext uri="{FF2B5EF4-FFF2-40B4-BE49-F238E27FC236}">
-                <a16:creationId xmlns:a16="http://schemas.microsoft.com/office/drawing/2014/main" id="{4E66DCA2-D2A8-B060-C0BE-790F82F2AD9C}"/>
+                <a16:creationId xmlns:a16="http://schemas.microsoft.com/office/drawing/2014/main" id="{4C8064FA-F54F-EACC-FDBF-444E81B9E0BE}"/>
               </a:ext>
             </a:extLst>
           </p:cNvPr>
@@ -4236,7 +4236,7 @@
                 </a:solidFill>
                 <a:latin typeface="Georgia" panose="02040502050405020303" pitchFamily="18" charset="0"/>
               </a:rPr>
-              <a:t>What the website already does well</a:t>
+              <a:t>Five strengths of the system</a:t>
             </a:r>
             <a:endParaRPr lang="en-PH" sz="2800" b="1">
               <a:solidFill>
@@ -4252,7 +4252,7 @@
           <p:cNvPr id="4" name="Straight Connector 3">
             <a:extLst>
               <a:ext uri="{FF2B5EF4-FFF2-40B4-BE49-F238E27FC236}">
-                <a16:creationId xmlns:a16="http://schemas.microsoft.com/office/drawing/2014/main" id="{AE1B292E-0750-CB4F-006B-DF248564B271}"/>
+                <a16:creationId xmlns:a16="http://schemas.microsoft.com/office/drawing/2014/main" id="{4F184F5C-04B7-4FA5-34AE-1BE3004E6A2A}"/>
               </a:ext>
             </a:extLst>
           </p:cNvPr>
@@ -4293,7 +4293,7 @@
           <p:cNvPr id="5" name="TextBox 4">
             <a:extLst>
               <a:ext uri="{FF2B5EF4-FFF2-40B4-BE49-F238E27FC236}">
-                <a16:creationId xmlns:a16="http://schemas.microsoft.com/office/drawing/2014/main" id="{6D012995-41ED-1AE8-D9D7-C018B1934504}"/>
+                <a16:creationId xmlns:a16="http://schemas.microsoft.com/office/drawing/2014/main" id="{16ACDD7C-195D-BC93-7A7A-F99DE2FD692B}"/>
               </a:ext>
             </a:extLst>
           </p:cNvPr>
@@ -4302,8 +4302,8 @@
         </p:nvSpPr>
         <p:spPr>
           <a:xfrm>
-            <a:off x="762000" y="1828800"/>
-            <a:ext cx="5080000" cy="2049151"/>
+            <a:off x="762000" y="1905000"/>
+            <a:ext cx="5080000" cy="1920910"/>
           </a:xfrm>
           <a:prstGeom prst="rect">
             <a:avLst/>
@@ -4331,7 +4331,7 @@
                 </a:solidFill>
                 <a:latin typeface="Calibri" panose="020F0502020204030204" pitchFamily="34" charset="0"/>
               </a:rPr>
-              <a:t>•  The menu is served from the database, so a dish marks itself sold out and disappears without anyone touching it.</a:t>
+              <a:t>•  The menu is always true. A dish hides itself once it runs out, so nobody makes a wasted trip.</a:t>
             </a:r>
           </a:p>
           <a:p>
@@ -4350,7 +4350,7 @@
                 </a:solidFill>
                 <a:latin typeface="Calibri" panose="020F0502020204030204" pitchFamily="34" charset="0"/>
               </a:rPr>
-              <a:t>•  Ordering needs no account and no app. Checkout issues a six-character ticket code to the phone.</a:t>
+              <a:t>•  Ordering suits everyone. A ticket code needs no account, and a free account adds order history, live tracking and loyalty rewards.</a:t>
             </a:r>
           </a:p>
           <a:p>
@@ -4369,9 +4369,44 @@
                 </a:solidFill>
                 <a:latin typeface="Calibri" panose="020F0502020204030204" pitchFamily="34" charset="0"/>
               </a:rPr>
-              <a:t>•  Prices are computed by the server, so a tampered browser cannot underpay. An automated test proves it.</a:t>
-            </a:r>
-          </a:p>
+              <a:t>•  The money side is safe and free to run. Totals and discount codes are worked out by the shop records, not the phone, and no payment company takes a cut.</a:t>
+            </a:r>
+            <a:endParaRPr lang="en-PH" sz="1300">
+              <a:solidFill>
+                <a:srgbClr val="2A1810"/>
+              </a:solidFill>
+              <a:latin typeface="Calibri" panose="020F0502020204030204" pitchFamily="34" charset="0"/>
+            </a:endParaRPr>
+          </a:p>
+        </p:txBody>
+      </p:sp>
+      <p:sp>
+        <p:nvSpPr>
+          <p:cNvPr id="6" name="TextBox 5">
+            <a:extLst>
+              <a:ext uri="{FF2B5EF4-FFF2-40B4-BE49-F238E27FC236}">
+                <a16:creationId xmlns:a16="http://schemas.microsoft.com/office/drawing/2014/main" id="{E451C972-1A34-DC2B-74AC-6225C45353A5}"/>
+              </a:ext>
+            </a:extLst>
+          </p:cNvPr>
+          <p:cNvSpPr txBox="1"/>
+          <p:nvPr/>
+        </p:nvSpPr>
+        <p:spPr>
+          <a:xfrm>
+            <a:off x="6350000" y="1905000"/>
+            <a:ext cx="5080000" cy="1552605"/>
+          </a:xfrm>
+          <a:prstGeom prst="rect">
+            <a:avLst/>
+          </a:prstGeom>
+          <a:noFill/>
+        </p:spPr>
+        <p:txBody>
+          <a:bodyPr vert="horz" wrap="square" lIns="0" tIns="0" rIns="0" bIns="0" rtlCol="0">
+            <a:spAutoFit/>
+          </a:bodyPr>
+          <a:lstStyle/>
           <a:p>
             <a:pPr>
               <a:lnSpc>
@@ -4388,44 +4423,9 @@
                 </a:solidFill>
                 <a:latin typeface="Calibri" panose="020F0502020204030204" pitchFamily="34" charset="0"/>
               </a:rPr>
-              <a:t>•  Promo codes are validated by the same database rule that charges them.</a:t>
-            </a:r>
-            <a:endParaRPr lang="en-PH" sz="1300">
-              <a:solidFill>
-                <a:srgbClr val="2A1810"/>
-              </a:solidFill>
-              <a:latin typeface="Calibri" panose="020F0502020204030204" pitchFamily="34" charset="0"/>
-            </a:endParaRPr>
-          </a:p>
-        </p:txBody>
-      </p:sp>
-      <p:sp>
-        <p:nvSpPr>
-          <p:cNvPr id="6" name="TextBox 5">
-            <a:extLst>
-              <a:ext uri="{FF2B5EF4-FFF2-40B4-BE49-F238E27FC236}">
-                <a16:creationId xmlns:a16="http://schemas.microsoft.com/office/drawing/2014/main" id="{73036707-2984-C9C3-9A5E-8538E24CCECF}"/>
-              </a:ext>
-            </a:extLst>
-          </p:cNvPr>
-          <p:cNvSpPr txBox="1"/>
-          <p:nvPr/>
-        </p:nvSpPr>
-        <p:spPr>
-          <a:xfrm>
-            <a:off x="6350000" y="1828800"/>
-            <a:ext cx="5080000" cy="2289216"/>
-          </a:xfrm>
-          <a:prstGeom prst="rect">
-            <a:avLst/>
-          </a:prstGeom>
-          <a:noFill/>
-        </p:spPr>
-        <p:txBody>
-          <a:bodyPr vert="horz" wrap="square" lIns="0" tIns="0" rIns="0" bIns="0" rtlCol="0">
-            <a:spAutoFit/>
-          </a:bodyPr>
-          <a:lstStyle/>
+              <a:t>•  The owner can finally run and measure the business: takings, profit, best sellers, stock levels, what to buy, and prices and staff logins they can change themselves.</a:t>
+            </a:r>
+          </a:p>
           <a:p>
             <a:pPr>
               <a:lnSpc>
@@ -4442,64 +4442,7 @@
                 </a:solidFill>
                 <a:latin typeface="Calibri" panose="020F0502020204030204" pitchFamily="34" charset="0"/>
               </a:rPr>
-              <a:t>•  GCash receipts are attached to the ticket and stored privately, giving an audit trail at no transaction fee.</a:t>
-            </a:r>
-          </a:p>
-          <a:p>
-            <a:pPr>
-              <a:lnSpc>
-                <a:spcPct val="120000"/>
-              </a:lnSpc>
-              <a:spcAft>
-                <a:spcPts val="1000"/>
-              </a:spcAft>
-            </a:pPr>
-            <a:r>
-              <a:rPr lang="en-US" sz="1300">
-                <a:solidFill>
-                  <a:srgbClr val="2A1810"/>
-                </a:solidFill>
-                <a:latin typeface="Calibri" panose="020F0502020204030204" pitchFamily="34" charset="0"/>
-              </a:rPr>
-              <a:t>•  The owner and the counter see different things, enforced by the database rather than by hidden buttons.</a:t>
-            </a:r>
-          </a:p>
-          <a:p>
-            <a:pPr>
-              <a:lnSpc>
-                <a:spcPct val="120000"/>
-              </a:lnSpc>
-              <a:spcAft>
-                <a:spcPts val="1000"/>
-              </a:spcAft>
-            </a:pPr>
-            <a:r>
-              <a:rPr lang="en-US" sz="1300">
-                <a:solidFill>
-                  <a:srgbClr val="2A1810"/>
-                </a:solidFill>
-                <a:latin typeface="Calibri" panose="020F0502020204030204" pitchFamily="34" charset="0"/>
-              </a:rPr>
-              <a:t>•  The owner dashboard finally measures the business: sales, best sellers, stock and net profit.</a:t>
-            </a:r>
-          </a:p>
-          <a:p>
-            <a:pPr>
-              <a:lnSpc>
-                <a:spcPct val="120000"/>
-              </a:lnSpc>
-              <a:spcAft>
-                <a:spcPts val="1000"/>
-              </a:spcAft>
-            </a:pPr>
-            <a:r>
-              <a:rPr lang="en-US" sz="1300">
-                <a:solidFill>
-                  <a:srgbClr val="2A1810"/>
-                </a:solidFill>
-                <a:latin typeface="Calibri" panose="020F0502020204030204" pitchFamily="34" charset="0"/>
-              </a:rPr>
-              <a:t>•  A landing page, trust pages, menu search, scarcity badges and one-tap reorder now exist.</a:t>
+              <a:t>•  One shop on every screen. Website, counter, dashboard, three mobile apps and an installable Android app share one identity and one set of records, and update each other live.</a:t>
             </a:r>
             <a:endParaRPr lang="en-PH" sz="1300">
               <a:solidFill>
@@ -4515,7 +4458,7 @@
           <p:cNvPr id="7" name="TextBox 6">
             <a:extLst>
               <a:ext uri="{FF2B5EF4-FFF2-40B4-BE49-F238E27FC236}">
-                <a16:creationId xmlns:a16="http://schemas.microsoft.com/office/drawing/2014/main" id="{81512955-100A-FFC3-AF3F-60B91623AA93}"/>
+                <a16:creationId xmlns:a16="http://schemas.microsoft.com/office/drawing/2014/main" id="{484D0B73-36F2-BAD1-9A1C-26E744EDF08B}"/>
               </a:ext>
             </a:extLst>
           </p:cNvPr>
@@ -4561,7 +4504,7 @@
           <p:cNvPr id="8" name="TextBox 7">
             <a:extLst>
               <a:ext uri="{FF2B5EF4-FFF2-40B4-BE49-F238E27FC236}">
-                <a16:creationId xmlns:a16="http://schemas.microsoft.com/office/drawing/2014/main" id="{DD25BAAF-174C-E6C5-0230-36FB51A47578}"/>
+                <a16:creationId xmlns:a16="http://schemas.microsoft.com/office/drawing/2014/main" id="{1359D18D-E2A4-96A3-8229-065637E2EDAC}"/>
               </a:ext>
             </a:extLst>
           </p:cNvPr>
@@ -4599,7 +4542,7 @@
     </p:spTree>
     <p:extLst>
       <p:ext uri="{BB962C8B-B14F-4D97-AF65-F5344CB8AC3E}">
-        <p14:creationId xmlns:p14="http://schemas.microsoft.com/office/powerpoint/2010/main" val="4101926564"/>
+        <p14:creationId xmlns:p14="http://schemas.microsoft.com/office/powerpoint/2010/main" val="130229342"/>
       </p:ext>
     </p:extLst>
   </p:cSld>
@@ -4639,7 +4582,7 @@
           <p:cNvPr id="2" name="TextBox 1">
             <a:extLst>
               <a:ext uri="{FF2B5EF4-FFF2-40B4-BE49-F238E27FC236}">
-                <a16:creationId xmlns:a16="http://schemas.microsoft.com/office/drawing/2014/main" id="{ACD4D509-E5B6-1BF7-AC4D-305F674D4A15}"/>
+                <a16:creationId xmlns:a16="http://schemas.microsoft.com/office/drawing/2014/main" id="{938E3301-9878-4E79-E734-DE6CB123B574}"/>
               </a:ext>
             </a:extLst>
           </p:cNvPr>
@@ -4685,7 +4628,7 @@
           <p:cNvPr id="3" name="TextBox 2">
             <a:extLst>
               <a:ext uri="{FF2B5EF4-FFF2-40B4-BE49-F238E27FC236}">
-                <a16:creationId xmlns:a16="http://schemas.microsoft.com/office/drawing/2014/main" id="{B9866899-102B-1711-3A86-2FEDBBC8FF9A}"/>
+                <a16:creationId xmlns:a16="http://schemas.microsoft.com/office/drawing/2014/main" id="{D730EA63-F47C-4F40-F7EF-5BE71F303A99}"/>
               </a:ext>
             </a:extLst>
           </p:cNvPr>
@@ -4709,20 +4652,14 @@
           <a:lstStyle/>
           <a:p>
             <a:r>
-              <a:rPr lang="en-US" sz="2800" b="1">
+              <a:rPr lang="en-PH" sz="2800" b="1">
                 <a:solidFill>
                   <a:srgbClr val="2A1810"/>
                 </a:solidFill>
                 <a:latin typeface="Georgia" panose="02040502050405020303" pitchFamily="18" charset="0"/>
               </a:rPr>
-              <a:t>What the website still needs</a:t>
-            </a:r>
-            <a:endParaRPr lang="en-PH" sz="2800" b="1">
-              <a:solidFill>
-                <a:srgbClr val="2A1810"/>
-              </a:solidFill>
-              <a:latin typeface="Georgia" panose="02040502050405020303" pitchFamily="18" charset="0"/>
-            </a:endParaRPr>
+              <a:t>Five opportunities that remain</a:t>
+            </a:r>
           </a:p>
         </p:txBody>
       </p:sp>
@@ -4731,7 +4668,7 @@
           <p:cNvPr id="4" name="Straight Connector 3">
             <a:extLst>
               <a:ext uri="{FF2B5EF4-FFF2-40B4-BE49-F238E27FC236}">
-                <a16:creationId xmlns:a16="http://schemas.microsoft.com/office/drawing/2014/main" id="{C82D9313-6886-4A77-35F1-10DA7D94E638}"/>
+                <a16:creationId xmlns:a16="http://schemas.microsoft.com/office/drawing/2014/main" id="{96DF774C-B59E-1C06-2EC8-5F85E7C4E779}"/>
               </a:ext>
             </a:extLst>
           </p:cNvPr>
@@ -4772,7 +4709,7 @@
           <p:cNvPr id="5" name="TextBox 4">
             <a:extLst>
               <a:ext uri="{FF2B5EF4-FFF2-40B4-BE49-F238E27FC236}">
-                <a16:creationId xmlns:a16="http://schemas.microsoft.com/office/drawing/2014/main" id="{49385BF2-A7AD-14A5-5E3A-89AC5F4DDC9D}"/>
+                <a16:creationId xmlns:a16="http://schemas.microsoft.com/office/drawing/2014/main" id="{EB35333E-5B2A-CF87-B84A-7B327374B7F2}"/>
               </a:ext>
             </a:extLst>
           </p:cNvPr>
@@ -4781,8 +4718,8 @@
         </p:nvSpPr>
         <p:spPr>
           <a:xfrm>
-            <a:off x="762000" y="1828800"/>
-            <a:ext cx="5080000" cy="1809085"/>
+            <a:off x="762000" y="1905000"/>
+            <a:ext cx="5080000" cy="1920910"/>
           </a:xfrm>
           <a:prstGeom prst="rect">
             <a:avLst/>
@@ -4810,7 +4747,7 @@
                 </a:solidFill>
                 <a:latin typeface="Calibri" panose="020F0502020204030204" pitchFamily="34" charset="0"/>
               </a:rPr>
-              <a:t>•  Ratings never leave the diner's own phone, so the site still shows no social proof.</a:t>
+              <a:t>•  Nobody can find Bencris online. It is not published, so a search for a karinderya in the Bayan finds nothing and the shop still lives on passing foot traffic.</a:t>
             </a:r>
           </a:p>
           <a:p>
@@ -4829,7 +4766,7 @@
                 </a:solidFill>
                 <a:latin typeface="Calibri" panose="020F0502020204030204" pitchFamily="34" charset="0"/>
               </a:rPr>
-              <a:t>•  The site is not published yet. There is no public address, so no customer can reach it.</a:t>
+              <a:t>•  The shop does not look like a real business yet. The address and contact number on the page are still placeholder text.</a:t>
             </a:r>
           </a:p>
           <a:p>
@@ -4848,9 +4785,44 @@
                 </a:solidFill>
                 <a:latin typeface="Calibri" panose="020F0502020204030204" pitchFamily="34" charset="0"/>
               </a:rPr>
-              <a:t>•  Nothing measures how the site is used, so cart abandonment is invisible.</a:t>
-            </a:r>
-          </a:p>
+              <a:t>•  The food does not look appetising. Every dish uses a stock picture, and several show the wrong food entirely.</a:t>
+            </a:r>
+            <a:endParaRPr lang="en-PH" sz="1300">
+              <a:solidFill>
+                <a:srgbClr val="2A1810"/>
+              </a:solidFill>
+              <a:latin typeface="Calibri" panose="020F0502020204030204" pitchFamily="34" charset="0"/>
+            </a:endParaRPr>
+          </a:p>
+        </p:txBody>
+      </p:sp>
+      <p:sp>
+        <p:nvSpPr>
+          <p:cNvPr id="6" name="TextBox 5">
+            <a:extLst>
+              <a:ext uri="{FF2B5EF4-FFF2-40B4-BE49-F238E27FC236}">
+                <a16:creationId xmlns:a16="http://schemas.microsoft.com/office/drawing/2014/main" id="{A956A8A7-2D72-7CA4-CCAA-5B44801006EF}"/>
+              </a:ext>
+            </a:extLst>
+          </p:cNvPr>
+          <p:cNvSpPr txBox="1"/>
+          <p:nvPr/>
+        </p:nvSpPr>
+        <p:spPr>
+          <a:xfrm>
+            <a:off x="6350000" y="1905000"/>
+            <a:ext cx="5080000" cy="1072473"/>
+          </a:xfrm>
+          <a:prstGeom prst="rect">
+            <a:avLst/>
+          </a:prstGeom>
+          <a:noFill/>
+        </p:spPr>
+        <p:txBody>
+          <a:bodyPr vert="horz" wrap="square" lIns="0" tIns="0" rIns="0" bIns="0" rtlCol="0">
+            <a:spAutoFit/>
+          </a:bodyPr>
+          <a:lstStyle/>
           <a:p>
             <a:pPr>
               <a:lnSpc>
@@ -4867,44 +4839,9 @@
                 </a:solidFill>
                 <a:latin typeface="Calibri" panose="020F0502020204030204" pitchFamily="34" charset="0"/>
               </a:rPr>
-              <a:t>•  The whole site downloads as one large file, which is slow on mobile data.</a:t>
-            </a:r>
-            <a:endParaRPr lang="en-PH" sz="1300">
-              <a:solidFill>
-                <a:srgbClr val="2A1810"/>
-              </a:solidFill>
-              <a:latin typeface="Calibri" panose="020F0502020204030204" pitchFamily="34" charset="0"/>
-            </a:endParaRPr>
-          </a:p>
-        </p:txBody>
-      </p:sp>
-      <p:sp>
-        <p:nvSpPr>
-          <p:cNvPr id="6" name="TextBox 5">
-            <a:extLst>
-              <a:ext uri="{FF2B5EF4-FFF2-40B4-BE49-F238E27FC236}">
-                <a16:creationId xmlns:a16="http://schemas.microsoft.com/office/drawing/2014/main" id="{E41AE8E1-CE70-2B65-DF01-0A15FF08732B}"/>
-              </a:ext>
-            </a:extLst>
-          </p:cNvPr>
-          <p:cNvSpPr txBox="1"/>
-          <p:nvPr/>
-        </p:nvSpPr>
-        <p:spPr>
-          <a:xfrm>
-            <a:off x="6350000" y="1828800"/>
-            <a:ext cx="5080000" cy="1809085"/>
-          </a:xfrm>
-          <a:prstGeom prst="rect">
-            <a:avLst/>
-          </a:prstGeom>
-          <a:noFill/>
-        </p:spPr>
-        <p:txBody>
-          <a:bodyPr vert="horz" wrap="square" lIns="0" tIns="0" rIns="0" bIns="0" rtlCol="0">
-            <a:spAutoFit/>
-          </a:bodyPr>
-          <a:lstStyle/>
+              <a:t>•  A first-time visitor sees no proof the food is good. Word of mouth is what this business runs on, and none of it is visible online.</a:t>
+            </a:r>
+          </a:p>
           <a:p>
             <a:pPr>
               <a:lnSpc>
@@ -4921,64 +4858,7 @@
                 </a:solidFill>
                 <a:latin typeface="Calibri" panose="020F0502020204030204" pitchFamily="34" charset="0"/>
               </a:rPr>
-              <a:t>•  The dish photographs are generic stock images, and several are wrong for the dish.</a:t>
-            </a:r>
-          </a:p>
-          <a:p>
-            <a:pPr>
-              <a:lnSpc>
-                <a:spcPct val="120000"/>
-              </a:lnSpc>
-              <a:spcAft>
-                <a:spcPts val="1000"/>
-              </a:spcAft>
-            </a:pPr>
-            <a:r>
-              <a:rPr lang="en-US" sz="1300">
-                <a:solidFill>
-                  <a:srgbClr val="2A1810"/>
-                </a:solidFill>
-                <a:latin typeface="Calibri" panose="020F0502020204030204" pitchFamily="34" charset="0"/>
-              </a:rPr>
-              <a:t>•  The address and contact number are still placeholders.</a:t>
-            </a:r>
-          </a:p>
-          <a:p>
-            <a:pPr>
-              <a:lnSpc>
-                <a:spcPct val="120000"/>
-              </a:lnSpc>
-              <a:spcAft>
-                <a:spcPts val="1000"/>
-              </a:spcAft>
-            </a:pPr>
-            <a:r>
-              <a:rPr lang="en-US" sz="1300">
-                <a:solidFill>
-                  <a:srgbClr val="2A1810"/>
-                </a:solidFill>
-                <a:latin typeface="Calibri" panose="020F0502020204030204" pitchFamily="34" charset="0"/>
-              </a:rPr>
-              <a:t>•  The owner cannot create a promo code without a developer.</a:t>
-            </a:r>
-          </a:p>
-          <a:p>
-            <a:pPr>
-              <a:lnSpc>
-                <a:spcPct val="120000"/>
-              </a:lnSpc>
-              <a:spcAft>
-                <a:spcPts val="1000"/>
-              </a:spcAft>
-            </a:pPr>
-            <a:r>
-              <a:rPr lang="en-US" sz="1300">
-                <a:solidFill>
-                  <a:srgbClr val="2A1810"/>
-                </a:solidFill>
-                <a:latin typeface="Calibri" panose="020F0502020204030204" pitchFamily="34" charset="0"/>
-              </a:rPr>
-              <a:t>•  There is still no QR code or referral code, so word of mouth cannot be captured.</a:t>
+              <a:t>•  There is no way to reach a customer once they leave. Every visit starts from scratch, so the business keeps winning the same customer again.</a:t>
             </a:r>
             <a:endParaRPr lang="en-PH" sz="1300">
               <a:solidFill>
@@ -4994,7 +4874,7 @@
           <p:cNvPr id="7" name="TextBox 6">
             <a:extLst>
               <a:ext uri="{FF2B5EF4-FFF2-40B4-BE49-F238E27FC236}">
-                <a16:creationId xmlns:a16="http://schemas.microsoft.com/office/drawing/2014/main" id="{0F4B1330-53A5-7DC0-4D26-29F1AE787800}"/>
+                <a16:creationId xmlns:a16="http://schemas.microsoft.com/office/drawing/2014/main" id="{89B99357-7643-F5A7-3888-C578AD9660AF}"/>
               </a:ext>
             </a:extLst>
           </p:cNvPr>
@@ -5040,7 +4920,7 @@
           <p:cNvPr id="8" name="TextBox 7">
             <a:extLst>
               <a:ext uri="{FF2B5EF4-FFF2-40B4-BE49-F238E27FC236}">
-                <a16:creationId xmlns:a16="http://schemas.microsoft.com/office/drawing/2014/main" id="{1270D3CF-D6EE-8677-1C2C-1EC4AA016403}"/>
+                <a16:creationId xmlns:a16="http://schemas.microsoft.com/office/drawing/2014/main" id="{D038C4D3-D289-ABE8-E615-6BC49773F9CF}"/>
               </a:ext>
             </a:extLst>
           </p:cNvPr>
@@ -5078,7 +4958,7 @@
     </p:spTree>
     <p:extLst>
       <p:ext uri="{BB962C8B-B14F-4D97-AF65-F5344CB8AC3E}">
-        <p14:creationId xmlns:p14="http://schemas.microsoft.com/office/powerpoint/2010/main" val="2777396884"/>
+        <p14:creationId xmlns:p14="http://schemas.microsoft.com/office/powerpoint/2010/main" val="975228595"/>
       </p:ext>
     </p:extLst>
   </p:cSld>
@@ -5118,7 +4998,7 @@
           <p:cNvPr id="2" name="TextBox 1">
             <a:extLst>
               <a:ext uri="{FF2B5EF4-FFF2-40B4-BE49-F238E27FC236}">
-                <a16:creationId xmlns:a16="http://schemas.microsoft.com/office/drawing/2014/main" id="{D4C0CEF4-4C1A-A8D9-A417-78B33A42F1EA}"/>
+                <a16:creationId xmlns:a16="http://schemas.microsoft.com/office/drawing/2014/main" id="{81C1E6B7-F409-04AB-CCB0-51D31751BDBF}"/>
               </a:ext>
             </a:extLst>
           </p:cNvPr>
@@ -5164,7 +5044,7 @@
           <p:cNvPr id="3" name="TextBox 2">
             <a:extLst>
               <a:ext uri="{FF2B5EF4-FFF2-40B4-BE49-F238E27FC236}">
-                <a16:creationId xmlns:a16="http://schemas.microsoft.com/office/drawing/2014/main" id="{89EDBA72-28D2-9417-B143-5085455C7E85}"/>
+                <a16:creationId xmlns:a16="http://schemas.microsoft.com/office/drawing/2014/main" id="{29B0858B-837D-96A5-10DF-895933AFBF43}"/>
               </a:ext>
             </a:extLst>
           </p:cNvPr>
@@ -5194,7 +5074,7 @@
                 </a:solidFill>
                 <a:latin typeface="Georgia" panose="02040502050405020303" pitchFamily="18" charset="0"/>
               </a:rPr>
-              <a:t>Growth built into the product itself</a:t>
+              <a:t>What we will do next, and why</a:t>
             </a:r>
             <a:endParaRPr lang="en-PH" sz="2800" b="1">
               <a:solidFill>
@@ -5210,7 +5090,7 @@
           <p:cNvPr id="4" name="Straight Connector 3">
             <a:extLst>
               <a:ext uri="{FF2B5EF4-FFF2-40B4-BE49-F238E27FC236}">
-                <a16:creationId xmlns:a16="http://schemas.microsoft.com/office/drawing/2014/main" id="{5005E785-096F-D221-7E29-AFC295C432F1}"/>
+                <a16:creationId xmlns:a16="http://schemas.microsoft.com/office/drawing/2014/main" id="{55AED4BD-D292-0439-DDDB-C319D204AC46}"/>
               </a:ext>
             </a:extLst>
           </p:cNvPr>
@@ -5251,7 +5131,7 @@
           <p:cNvPr id="5" name="TextBox 4">
             <a:extLst>
               <a:ext uri="{FF2B5EF4-FFF2-40B4-BE49-F238E27FC236}">
-                <a16:creationId xmlns:a16="http://schemas.microsoft.com/office/drawing/2014/main" id="{3307D652-DB7E-91E3-3224-E8542D50B4F1}"/>
+                <a16:creationId xmlns:a16="http://schemas.microsoft.com/office/drawing/2014/main" id="{2E86F2D3-B5FE-F0AE-AFE6-7FEF7343F9DE}"/>
               </a:ext>
             </a:extLst>
           </p:cNvPr>
@@ -5281,7 +5161,7 @@
                 </a:solidFill>
                 <a:latin typeface="Calibri" panose="020F0502020204030204" pitchFamily="34" charset="0"/>
               </a:rPr>
-              <a:t>There is no social page to maintain. The website itself is the marketing channel, and every mechanism below is free to run.</a:t>
+              <a:t>Seven areas, each closing one weakness from Part 1. DONE is already built; NEXT is what remains. Everything here is free to run.</a:t>
             </a:r>
             <a:endParaRPr lang="en-PH" sz="1300">
               <a:solidFill>
@@ -5297,7 +5177,7 @@
           <p:cNvPr id="6" name="Rectangle: Rounded Corners 5">
             <a:extLst>
               <a:ext uri="{FF2B5EF4-FFF2-40B4-BE49-F238E27FC236}">
-                <a16:creationId xmlns:a16="http://schemas.microsoft.com/office/drawing/2014/main" id="{333E15D8-986A-EF1C-B812-CEA06BE68521}"/>
+                <a16:creationId xmlns:a16="http://schemas.microsoft.com/office/drawing/2014/main" id="{79C2A2D3-EEB8-6B2E-C142-51A4BD858770}"/>
               </a:ext>
             </a:extLst>
           </p:cNvPr>
@@ -5353,7 +5233,7 @@
           <p:cNvPr id="7" name="TextBox 6">
             <a:extLst>
               <a:ext uri="{FF2B5EF4-FFF2-40B4-BE49-F238E27FC236}">
-                <a16:creationId xmlns:a16="http://schemas.microsoft.com/office/drawing/2014/main" id="{3D202D0D-6152-9030-4892-A6A0DEB69764}"/>
+                <a16:creationId xmlns:a16="http://schemas.microsoft.com/office/drawing/2014/main" id="{4FA3F899-EECE-AFE5-041F-7C35F47EA452}"/>
               </a:ext>
             </a:extLst>
           </p:cNvPr>
@@ -5383,7 +5263,7 @@
                 </a:solidFill>
                 <a:latin typeface="Georgia" panose="02040502050405020303" pitchFamily="18" charset="0"/>
               </a:rPr>
-              <a:t>Shareable menu link</a:t>
+              <a:t>Branding</a:t>
             </a:r>
           </a:p>
         </p:txBody>
@@ -5393,7 +5273,7 @@
           <p:cNvPr id="8" name="TextBox 7">
             <a:extLst>
               <a:ext uri="{FF2B5EF4-FFF2-40B4-BE49-F238E27FC236}">
-                <a16:creationId xmlns:a16="http://schemas.microsoft.com/office/drawing/2014/main" id="{447A7F4D-AB54-F511-926A-3AE80BF9CF02}"/>
+                <a16:creationId xmlns:a16="http://schemas.microsoft.com/office/drawing/2014/main" id="{93E527BC-078B-E641-1C77-1CCF7A5003F9}"/>
               </a:ext>
             </a:extLst>
           </p:cNvPr>
@@ -5403,7 +5283,7 @@
         <p:spPr>
           <a:xfrm>
             <a:off x="990600" y="2794000"/>
-            <a:ext cx="2971800" cy="507831"/>
+            <a:ext cx="2971800" cy="677108"/>
           </a:xfrm>
           <a:prstGeom prst="rect">
             <a:avLst/>
@@ -5423,7 +5303,18 @@
                 </a:solidFill>
                 <a:latin typeface="Calibri" panose="020F0502020204030204" pitchFamily="34" charset="0"/>
               </a:rPr>
-              <a:t>The link previews with the shop name and a dish photo, so a diner can drop Bencris into a group chat in one tap.</a:t>
+              <a:t>DONE  One identity on every screen and all three apps, shop details stored once.</a:t>
+            </a:r>
+          </a:p>
+          <a:p>
+            <a:r>
+              <a:rPr lang="en-US" sz="1100">
+                <a:solidFill>
+                  <a:srgbClr val="6B5546"/>
+                </a:solidFill>
+                <a:latin typeface="Calibri" panose="020F0502020204030204" pitchFamily="34" charset="0"/>
+              </a:rPr>
+              <a:t>NEXT  Put the owner real address and contact in, and agree a mark and colour.</a:t>
             </a:r>
             <a:endParaRPr lang="en-PH" sz="1100">
               <a:solidFill>
@@ -5439,7 +5330,7 @@
           <p:cNvPr id="9" name="Rectangle: Rounded Corners 8">
             <a:extLst>
               <a:ext uri="{FF2B5EF4-FFF2-40B4-BE49-F238E27FC236}">
-                <a16:creationId xmlns:a16="http://schemas.microsoft.com/office/drawing/2014/main" id="{A3DC7BB7-237B-D2EA-D218-39C654CF4EEB}"/>
+                <a16:creationId xmlns:a16="http://schemas.microsoft.com/office/drawing/2014/main" id="{4540F1ED-7B7C-C9A2-0A0E-876ADD387DBC}"/>
               </a:ext>
             </a:extLst>
           </p:cNvPr>
@@ -5495,7 +5386,7 @@
           <p:cNvPr id="10" name="TextBox 9">
             <a:extLst>
               <a:ext uri="{FF2B5EF4-FFF2-40B4-BE49-F238E27FC236}">
-                <a16:creationId xmlns:a16="http://schemas.microsoft.com/office/drawing/2014/main" id="{1B7E10D9-8BCA-B92C-B925-C5372756BB72}"/>
+                <a16:creationId xmlns:a16="http://schemas.microsoft.com/office/drawing/2014/main" id="{F1E94906-217E-81FB-0B14-68B79BACAD1E}"/>
               </a:ext>
             </a:extLst>
           </p:cNvPr>
@@ -5525,7 +5416,7 @@
                 </a:solidFill>
                 <a:latin typeface="Georgia" panose="02040502050405020303" pitchFamily="18" charset="0"/>
               </a:rPr>
-              <a:t>Share on the receipt</a:t>
+              <a:t>UX</a:t>
             </a:r>
           </a:p>
         </p:txBody>
@@ -5535,7 +5426,7 @@
           <p:cNvPr id="11" name="TextBox 10">
             <a:extLst>
               <a:ext uri="{FF2B5EF4-FFF2-40B4-BE49-F238E27FC236}">
-                <a16:creationId xmlns:a16="http://schemas.microsoft.com/office/drawing/2014/main" id="{6AD951E0-95A8-F4BF-7828-A668B7DE6734}"/>
+                <a16:creationId xmlns:a16="http://schemas.microsoft.com/office/drawing/2014/main" id="{34F3A71A-7994-4B53-4DA6-8242076F110E}"/>
               </a:ext>
             </a:extLst>
           </p:cNvPr>
@@ -5545,7 +5436,7 @@
         <p:spPr>
           <a:xfrm>
             <a:off x="4673600" y="2794000"/>
-            <a:ext cx="2971800" cy="338554"/>
+            <a:ext cx="2971800" cy="677108"/>
           </a:xfrm>
           <a:prstGeom prst="rect">
             <a:avLst/>
@@ -5565,7 +5456,18 @@
                 </a:solidFill>
                 <a:latin typeface="Calibri" panose="020F0502020204030204" pitchFamily="34" charset="0"/>
               </a:rPr>
-              <a:t>A Share action on the receipt turns every satisfied diner into a distribution channel at no cost.</a:t>
+              <a:t>DONE  Four taps to order, cart within thumb reach, menu search, one-tap reorder.</a:t>
+            </a:r>
+          </a:p>
+          <a:p>
+            <a:r>
+              <a:rPr lang="en-US" sz="1100">
+                <a:solidFill>
+                  <a:srgbClr val="6B5546"/>
+                </a:solidFill>
+                <a:latin typeface="Calibri" panose="020F0502020204030204" pitchFamily="34" charset="0"/>
+              </a:rPr>
+              <a:t>NEXT  Walk the whole path on a cheap phone on mobile data and fix what is slow.</a:t>
             </a:r>
             <a:endParaRPr lang="en-PH" sz="1100">
               <a:solidFill>
@@ -5581,7 +5483,7 @@
           <p:cNvPr id="12" name="Rectangle: Rounded Corners 11">
             <a:extLst>
               <a:ext uri="{FF2B5EF4-FFF2-40B4-BE49-F238E27FC236}">
-                <a16:creationId xmlns:a16="http://schemas.microsoft.com/office/drawing/2014/main" id="{31C5E37E-E230-6D54-A67D-1AE5B25686AD}"/>
+                <a16:creationId xmlns:a16="http://schemas.microsoft.com/office/drawing/2014/main" id="{D5EB5585-85D8-DC33-1A10-4DA307084B64}"/>
               </a:ext>
             </a:extLst>
           </p:cNvPr>
@@ -5637,7 +5539,7 @@
           <p:cNvPr id="13" name="TextBox 12">
             <a:extLst>
               <a:ext uri="{FF2B5EF4-FFF2-40B4-BE49-F238E27FC236}">
-                <a16:creationId xmlns:a16="http://schemas.microsoft.com/office/drawing/2014/main" id="{9965FA81-1297-2AA0-F7EE-A38F81DF5F07}"/>
+                <a16:creationId xmlns:a16="http://schemas.microsoft.com/office/drawing/2014/main" id="{826F0571-98D4-EE6D-2DF5-6F3B4BE8784D}"/>
               </a:ext>
             </a:extLst>
           </p:cNvPr>
@@ -5667,7 +5569,7 @@
                 </a:solidFill>
                 <a:latin typeface="Georgia" panose="02040502050405020303" pitchFamily="18" charset="0"/>
               </a:rPr>
-              <a:t>Referral codes</a:t>
+              <a:t>SEO</a:t>
             </a:r>
           </a:p>
         </p:txBody>
@@ -5677,7 +5579,7 @@
           <p:cNvPr id="14" name="TextBox 13">
             <a:extLst>
               <a:ext uri="{FF2B5EF4-FFF2-40B4-BE49-F238E27FC236}">
-                <a16:creationId xmlns:a16="http://schemas.microsoft.com/office/drawing/2014/main" id="{ED5238BE-8244-9F4A-7AAA-A9D6418E6C0E}"/>
+                <a16:creationId xmlns:a16="http://schemas.microsoft.com/office/drawing/2014/main" id="{E83A203B-87AB-5EB4-78FE-4A3CC5613AD1}"/>
               </a:ext>
             </a:extLst>
           </p:cNvPr>
@@ -5687,7 +5589,7 @@
         <p:spPr>
           <a:xfrm>
             <a:off x="8356600" y="2794000"/>
-            <a:ext cx="2971800" cy="507831"/>
+            <a:ext cx="2971800" cy="677108"/>
           </a:xfrm>
           <a:prstGeom prst="rect">
             <a:avLst/>
@@ -5707,7 +5609,18 @@
                 </a:solidFill>
                 <a:latin typeface="Calibri" panose="020F0502020204030204" pitchFamily="34" charset="0"/>
               </a:rPr>
-              <a:t>A personal code rewards the diner who brings a friend, and costs a discount only when it produces a sale.</a:t>
+              <a:t>DONE  Real text naming the shop and the area, dishes in Tagalog and English.</a:t>
+            </a:r>
+          </a:p>
+          <a:p>
+            <a:r>
+              <a:rPr lang="en-US" sz="1100">
+                <a:solidFill>
+                  <a:srgbClr val="6B5546"/>
+                </a:solidFill>
+                <a:latin typeface="Calibri" panose="020F0502020204030204" pitchFamily="34" charset="0"/>
+              </a:rPr>
+              <a:t>NEXT  Publish with a real address, and add hours and prices in the form search engines read.</a:t>
             </a:r>
             <a:endParaRPr lang="en-PH" sz="1100">
               <a:solidFill>
@@ -5723,7 +5636,7 @@
           <p:cNvPr id="15" name="Rectangle: Rounded Corners 14">
             <a:extLst>
               <a:ext uri="{FF2B5EF4-FFF2-40B4-BE49-F238E27FC236}">
-                <a16:creationId xmlns:a16="http://schemas.microsoft.com/office/drawing/2014/main" id="{CC1058C1-3E5D-E81B-AFAD-34670A157605}"/>
+                <a16:creationId xmlns:a16="http://schemas.microsoft.com/office/drawing/2014/main" id="{E1E490BF-DE02-93B7-7743-B1B9F88FC531}"/>
               </a:ext>
             </a:extLst>
           </p:cNvPr>
@@ -5779,7 +5692,7 @@
           <p:cNvPr id="16" name="TextBox 15">
             <a:extLst>
               <a:ext uri="{FF2B5EF4-FFF2-40B4-BE49-F238E27FC236}">
-                <a16:creationId xmlns:a16="http://schemas.microsoft.com/office/drawing/2014/main" id="{B5EAA1DB-0E8E-7FEE-A74E-E584383E0830}"/>
+                <a16:creationId xmlns:a16="http://schemas.microsoft.com/office/drawing/2014/main" id="{A9F0D06B-242E-7C9C-5A07-B3610B991258}"/>
               </a:ext>
             </a:extLst>
           </p:cNvPr>
@@ -5803,20 +5716,14 @@
           <a:lstStyle/>
           <a:p>
             <a:r>
-              <a:rPr lang="en-US" sz="1400" b="1">
+              <a:rPr lang="en-PH" sz="1400" b="1">
                 <a:solidFill>
                   <a:srgbClr val="2A1810"/>
                 </a:solidFill>
                 <a:latin typeface="Georgia" panose="02040502050405020303" pitchFamily="18" charset="0"/>
               </a:rPr>
-              <a:t>QR code at the counter</a:t>
-            </a:r>
-            <a:endParaRPr lang="en-PH" sz="1400" b="1">
-              <a:solidFill>
-                <a:srgbClr val="2A1810"/>
-              </a:solidFill>
-              <a:latin typeface="Georgia" panose="02040502050405020303" pitchFamily="18" charset="0"/>
-            </a:endParaRPr>
+              <a:t>Product presentation</a:t>
+            </a:r>
           </a:p>
         </p:txBody>
       </p:sp>
@@ -5825,7 +5732,7 @@
           <p:cNvPr id="17" name="TextBox 16">
             <a:extLst>
               <a:ext uri="{FF2B5EF4-FFF2-40B4-BE49-F238E27FC236}">
-                <a16:creationId xmlns:a16="http://schemas.microsoft.com/office/drawing/2014/main" id="{5B6B53B6-1B98-0887-CAFE-FFC43D718BCF}"/>
+                <a16:creationId xmlns:a16="http://schemas.microsoft.com/office/drawing/2014/main" id="{35AE49B0-6F0F-5FD4-B8D7-EE7C39618875}"/>
               </a:ext>
             </a:extLst>
           </p:cNvPr>
@@ -5835,7 +5742,7 @@
         <p:spPr>
           <a:xfrm>
             <a:off x="990600" y="4851400"/>
-            <a:ext cx="2971800" cy="338554"/>
+            <a:ext cx="2971800" cy="677108"/>
           </a:xfrm>
           <a:prstGeom prst="rect">
             <a:avLst/>
@@ -5855,7 +5762,18 @@
                 </a:solidFill>
                 <a:latin typeface="Calibri" panose="020F0502020204030204" pitchFamily="34" charset="0"/>
               </a:rPr>
-              <a:t>A QR displayed at the counter turns today's walk-in customer into tomorrow's online order.</a:t>
+              <a:t>DONE  Bestseller, Only a few left and Sold out labels from real sales and stock.</a:t>
+            </a:r>
+          </a:p>
+          <a:p>
+            <a:r>
+              <a:rPr lang="en-US" sz="1100">
+                <a:solidFill>
+                  <a:srgbClr val="6B5546"/>
+                </a:solidFill>
+                <a:latin typeface="Calibri" panose="020F0502020204030204" pitchFamily="34" charset="0"/>
+              </a:rPr>
+              <a:t>NEXT  Photograph every dish in daylight and replace all the stock pictures.</a:t>
             </a:r>
             <a:endParaRPr lang="en-PH" sz="1100">
               <a:solidFill>
@@ -5871,7 +5789,7 @@
           <p:cNvPr id="18" name="Rectangle: Rounded Corners 17">
             <a:extLst>
               <a:ext uri="{FF2B5EF4-FFF2-40B4-BE49-F238E27FC236}">
-                <a16:creationId xmlns:a16="http://schemas.microsoft.com/office/drawing/2014/main" id="{B9B969A4-6360-4EAE-E5CE-2A3704990183}"/>
+                <a16:creationId xmlns:a16="http://schemas.microsoft.com/office/drawing/2014/main" id="{B0463E65-6244-B406-C8E3-2B6710CBEEC5}"/>
               </a:ext>
             </a:extLst>
           </p:cNvPr>
@@ -5927,7 +5845,7 @@
           <p:cNvPr id="19" name="TextBox 18">
             <a:extLst>
               <a:ext uri="{FF2B5EF4-FFF2-40B4-BE49-F238E27FC236}">
-                <a16:creationId xmlns:a16="http://schemas.microsoft.com/office/drawing/2014/main" id="{6E6BD4EA-5B3D-0E10-005A-0AAF9489C664}"/>
+                <a16:creationId xmlns:a16="http://schemas.microsoft.com/office/drawing/2014/main" id="{2A07247C-44FE-E0C4-AD51-EA054605B475}"/>
               </a:ext>
             </a:extLst>
           </p:cNvPr>
@@ -5957,7 +5875,7 @@
                 </a:solidFill>
                 <a:latin typeface="Georgia" panose="02040502050405020303" pitchFamily="18" charset="0"/>
               </a:rPr>
-              <a:t>Timed promotional codes</a:t>
+              <a:t>Trust</a:t>
             </a:r>
           </a:p>
         </p:txBody>
@@ -5967,7 +5885,7 @@
           <p:cNvPr id="20" name="TextBox 19">
             <a:extLst>
               <a:ext uri="{FF2B5EF4-FFF2-40B4-BE49-F238E27FC236}">
-                <a16:creationId xmlns:a16="http://schemas.microsoft.com/office/drawing/2014/main" id="{C4DE2C05-2FD5-147E-9E7B-4D9F3570EF63}"/>
+                <a16:creationId xmlns:a16="http://schemas.microsoft.com/office/drawing/2014/main" id="{692D0010-37E3-F391-B4EE-B969F4AA16A7}"/>
               </a:ext>
             </a:extLst>
           </p:cNvPr>
@@ -5977,7 +5895,7 @@
         <p:spPr>
           <a:xfrm>
             <a:off x="4673600" y="4851400"/>
-            <a:ext cx="2971800" cy="338554"/>
+            <a:ext cx="2971800" cy="677108"/>
           </a:xfrm>
           <a:prstGeom prst="rect">
             <a:avLst/>
@@ -5997,7 +5915,18 @@
                 </a:solidFill>
                 <a:latin typeface="Calibri" panose="020F0502020204030204" pitchFamily="34" charset="0"/>
               </a:rPr>
-              <a:t>A code such as HAPON15 runs only between 2 and 4 PM, pulling demand into the quiet hours.</a:t>
+              <a:t>DONE  Hours, address and open-now up front, trust pages, and ratings only a paid ticket can leave.</a:t>
+            </a:r>
+          </a:p>
+          <a:p>
+            <a:r>
+              <a:rPr lang="en-US" sz="1100">
+                <a:solidFill>
+                  <a:srgbClr val="6B5546"/>
+                </a:solidFill>
+                <a:latin typeface="Calibri" panose="020F0502020204030204" pitchFamily="34" charset="0"/>
+              </a:rPr>
+              <a:t>NEXT  Gather the first real ratings once the shop is live.</a:t>
             </a:r>
             <a:endParaRPr lang="en-PH" sz="1100">
               <a:solidFill>
@@ -6013,7 +5942,7 @@
           <p:cNvPr id="21" name="Rectangle: Rounded Corners 20">
             <a:extLst>
               <a:ext uri="{FF2B5EF4-FFF2-40B4-BE49-F238E27FC236}">
-                <a16:creationId xmlns:a16="http://schemas.microsoft.com/office/drawing/2014/main" id="{6A7C6403-F8EA-0A53-2AE3-7AE797BB2372}"/>
+                <a16:creationId xmlns:a16="http://schemas.microsoft.com/office/drawing/2014/main" id="{28DAACF0-BD60-18DD-B031-9D4155D0B4FC}"/>
               </a:ext>
             </a:extLst>
           </p:cNvPr>
@@ -6069,7 +5998,7 @@
           <p:cNvPr id="22" name="TextBox 21">
             <a:extLst>
               <a:ext uri="{FF2B5EF4-FFF2-40B4-BE49-F238E27FC236}">
-                <a16:creationId xmlns:a16="http://schemas.microsoft.com/office/drawing/2014/main" id="{494DC9F5-9A66-8308-9771-4C8F569BD185}"/>
+                <a16:creationId xmlns:a16="http://schemas.microsoft.com/office/drawing/2014/main" id="{DC2B8386-3D92-279B-E958-2306599BA0FC}"/>
               </a:ext>
             </a:extLst>
           </p:cNvPr>
@@ -6099,7 +6028,7 @@
                 </a:solidFill>
                 <a:latin typeface="Georgia" panose="02040502050405020303" pitchFamily="18" charset="0"/>
               </a:rPr>
-              <a:t>Verified reviews</a:t>
+              <a:t>Marketing and engagement</a:t>
             </a:r>
           </a:p>
         </p:txBody>
@@ -6109,7 +6038,7 @@
           <p:cNvPr id="23" name="TextBox 22">
             <a:extLst>
               <a:ext uri="{FF2B5EF4-FFF2-40B4-BE49-F238E27FC236}">
-                <a16:creationId xmlns:a16="http://schemas.microsoft.com/office/drawing/2014/main" id="{791FD376-07F5-945B-ECD0-D23CADE28CBF}"/>
+                <a16:creationId xmlns:a16="http://schemas.microsoft.com/office/drawing/2014/main" id="{7FD92232-8C25-A2EF-73CB-C34C9BE80D7B}"/>
               </a:ext>
             </a:extLst>
           </p:cNvPr>
@@ -6119,7 +6048,7 @@
         <p:spPr>
           <a:xfrm>
             <a:off x="8356600" y="4851400"/>
-            <a:ext cx="2971800" cy="338554"/>
+            <a:ext cx="2971800" cy="677108"/>
           </a:xfrm>
           <a:prstGeom prst="rect">
             <a:avLst/>
@@ -6139,7 +6068,18 @@
                 </a:solidFill>
                 <a:latin typeface="Calibri" panose="020F0502020204030204" pitchFamily="34" charset="0"/>
               </a:rPr>
-              <a:t>Only a ticket code that was actually paid can leave a rating, so the reviews cannot be faked.</a:t>
+              <a:t>DONE  Discount codes, a printable QR poster, accounts with history and loyalty.</a:t>
+            </a:r>
+          </a:p>
+          <a:p>
+            <a:r>
+              <a:rPr lang="en-US" sz="1100">
+                <a:solidFill>
+                  <a:srgbClr val="6B5546"/>
+                </a:solidFill>
+                <a:latin typeface="Calibri" panose="020F0502020204030204" pitchFamily="34" charset="0"/>
+              </a:rPr>
+              <a:t>NEXT  Put the poster up, run a quiet-hours discount, and notify when food is ready.</a:t>
             </a:r>
             <a:endParaRPr lang="en-PH" sz="1100">
               <a:solidFill>
@@ -6155,7 +6095,7 @@
           <p:cNvPr id="24" name="TextBox 23">
             <a:extLst>
               <a:ext uri="{FF2B5EF4-FFF2-40B4-BE49-F238E27FC236}">
-                <a16:creationId xmlns:a16="http://schemas.microsoft.com/office/drawing/2014/main" id="{5111BAE2-0B24-90C1-2F03-298E2A13965E}"/>
+                <a16:creationId xmlns:a16="http://schemas.microsoft.com/office/drawing/2014/main" id="{0BA32DEC-B9D4-1949-EA48-8C71604F5AD7}"/>
               </a:ext>
             </a:extLst>
           </p:cNvPr>
@@ -6201,7 +6141,7 @@
           <p:cNvPr id="25" name="TextBox 24">
             <a:extLst>
               <a:ext uri="{FF2B5EF4-FFF2-40B4-BE49-F238E27FC236}">
-                <a16:creationId xmlns:a16="http://schemas.microsoft.com/office/drawing/2014/main" id="{34DFDECA-AB2E-7753-A607-7AA8ECE56AC6}"/>
+                <a16:creationId xmlns:a16="http://schemas.microsoft.com/office/drawing/2014/main" id="{B06B2E1C-B9F5-2838-9CFB-B99E6B798C35}"/>
               </a:ext>
             </a:extLst>
           </p:cNvPr>
@@ -6239,7 +6179,7 @@
     </p:spTree>
     <p:extLst>
       <p:ext uri="{BB962C8B-B14F-4D97-AF65-F5344CB8AC3E}">
-        <p14:creationId xmlns:p14="http://schemas.microsoft.com/office/powerpoint/2010/main" val="30226678"/>
+        <p14:creationId xmlns:p14="http://schemas.microsoft.com/office/powerpoint/2010/main" val="1896098392"/>
       </p:ext>
     </p:extLst>
   </p:cSld>
@@ -6279,7 +6219,7 @@
           <p:cNvPr id="2" name="TextBox 1">
             <a:extLst>
               <a:ext uri="{FF2B5EF4-FFF2-40B4-BE49-F238E27FC236}">
-                <a16:creationId xmlns:a16="http://schemas.microsoft.com/office/drawing/2014/main" id="{E3756D5F-2F70-8801-EB04-6A74F5592702}"/>
+                <a16:creationId xmlns:a16="http://schemas.microsoft.com/office/drawing/2014/main" id="{AD78943B-EDE7-825A-963E-82230F0AC81B}"/>
               </a:ext>
             </a:extLst>
           </p:cNvPr>
@@ -6325,7 +6265,7 @@
           <p:cNvPr id="3" name="TextBox 2">
             <a:extLst>
               <a:ext uri="{FF2B5EF4-FFF2-40B4-BE49-F238E27FC236}">
-                <a16:creationId xmlns:a16="http://schemas.microsoft.com/office/drawing/2014/main" id="{B9851C92-4335-566C-66D6-2F19E22F2C6B}"/>
+                <a16:creationId xmlns:a16="http://schemas.microsoft.com/office/drawing/2014/main" id="{35DCE768-3F5E-A4D9-17AC-887E72741F75}"/>
               </a:ext>
             </a:extLst>
           </p:cNvPr>
@@ -6371,7 +6311,7 @@
           <p:cNvPr id="4" name="Straight Connector 3">
             <a:extLst>
               <a:ext uri="{FF2B5EF4-FFF2-40B4-BE49-F238E27FC236}">
-                <a16:creationId xmlns:a16="http://schemas.microsoft.com/office/drawing/2014/main" id="{B7F6656F-6896-E50B-BE76-682F6FCD1880}"/>
+                <a16:creationId xmlns:a16="http://schemas.microsoft.com/office/drawing/2014/main" id="{FB0CD6F3-B89C-D4EA-A553-1C4A24EC37EE}"/>
               </a:ext>
             </a:extLst>
           </p:cNvPr>
@@ -6412,7 +6352,7 @@
           <p:cNvPr id="5" name="TextBox 4">
             <a:extLst>
               <a:ext uri="{FF2B5EF4-FFF2-40B4-BE49-F238E27FC236}">
-                <a16:creationId xmlns:a16="http://schemas.microsoft.com/office/drawing/2014/main" id="{D9995B94-F7DE-5FBE-8D5F-308040A4EBBE}"/>
+                <a16:creationId xmlns:a16="http://schemas.microsoft.com/office/drawing/2014/main" id="{52DE9EA2-5B78-0D0F-E1EC-C170B05B3F16}"/>
               </a:ext>
             </a:extLst>
           </p:cNvPr>
@@ -6422,7 +6362,7 @@
         <p:spPr>
           <a:xfrm>
             <a:off x="762000" y="2032000"/>
-            <a:ext cx="4826000" cy="1680845"/>
+            <a:ext cx="4826000" cy="2529282"/>
           </a:xfrm>
           <a:prstGeom prst="rect">
             <a:avLst/>
@@ -6450,7 +6390,7 @@
                 </a:solidFill>
                 <a:latin typeface="Calibri" panose="020F0502020204030204" pitchFamily="34" charset="0"/>
               </a:rPr>
-              <a:t>•  Discovery now has three doors: a link forwarded in a chat, the QR at the counter, or a web search.</a:t>
+              <a:t>•  Discovery now has three doors: a link forwarded in a chat, the printed QR poster on the wall, or a web search.</a:t>
             </a:r>
           </a:p>
           <a:p>
@@ -6488,7 +6428,26 @@
                 </a:solidFill>
                 <a:latin typeface="Calibri" panose="020F0502020204030204" pitchFamily="34" charset="0"/>
               </a:rPr>
-              <a:t>•  Two loops close the journey: a reorder returns the diner to Browse, and a shared receipt starts a new person at Discover.</a:t>
+              <a:t>•  Waiting is no longer guesswork. The diner watches the order move from preparing to ready.</a:t>
+            </a:r>
+          </a:p>
+          <a:p>
+            <a:pPr>
+              <a:lnSpc>
+                <a:spcPct val="120000"/>
+              </a:lnSpc>
+              <a:spcAft>
+                <a:spcPts val="1000"/>
+              </a:spcAft>
+            </a:pPr>
+            <a:r>
+              <a:rPr lang="en-US" sz="1300">
+                <a:solidFill>
+                  <a:srgbClr val="2A1810"/>
+                </a:solidFill>
+                <a:latin typeface="Calibri" panose="020F0502020204030204" pitchFamily="34" charset="0"/>
+              </a:rPr>
+              <a:t>•  Two loops close the journey: a reorder returns the diner to Browse, and a shared receipt or a scanned poster starts a new person at Discover.</a:t>
             </a:r>
             <a:endParaRPr lang="en-PH" sz="1300">
               <a:solidFill>
@@ -6504,7 +6463,7 @@
           <p:cNvPr id="7" name="Picture 6">
             <a:extLst>
               <a:ext uri="{FF2B5EF4-FFF2-40B4-BE49-F238E27FC236}">
-                <a16:creationId xmlns:a16="http://schemas.microsoft.com/office/drawing/2014/main" id="{4E10AAB6-781F-ADD9-CDD1-96AF540973F9}"/>
+                <a16:creationId xmlns:a16="http://schemas.microsoft.com/office/drawing/2014/main" id="{D19C39B2-C1FD-6EC0-78EF-329AAD98F67B}"/>
               </a:ext>
             </a:extLst>
           </p:cNvPr>
@@ -6540,7 +6499,7 @@
           <p:cNvPr id="8" name="TextBox 7">
             <a:extLst>
               <a:ext uri="{FF2B5EF4-FFF2-40B4-BE49-F238E27FC236}">
-                <a16:creationId xmlns:a16="http://schemas.microsoft.com/office/drawing/2014/main" id="{2E95294A-19CD-3D15-EB53-EB2B4E209A1C}"/>
+                <a16:creationId xmlns:a16="http://schemas.microsoft.com/office/drawing/2014/main" id="{53B39E42-0970-A314-E6DA-704AD7B6B87F}"/>
               </a:ext>
             </a:extLst>
           </p:cNvPr>
@@ -6586,7 +6545,7 @@
           <p:cNvPr id="9" name="TextBox 8">
             <a:extLst>
               <a:ext uri="{FF2B5EF4-FFF2-40B4-BE49-F238E27FC236}">
-                <a16:creationId xmlns:a16="http://schemas.microsoft.com/office/drawing/2014/main" id="{6C4B8CD3-13DF-47EB-5E62-430F842168B7}"/>
+                <a16:creationId xmlns:a16="http://schemas.microsoft.com/office/drawing/2014/main" id="{7B469A98-2165-1094-3CDE-A50C63B2E792}"/>
               </a:ext>
             </a:extLst>
           </p:cNvPr>
@@ -6624,7 +6583,7 @@
     </p:spTree>
     <p:extLst>
       <p:ext uri="{BB962C8B-B14F-4D97-AF65-F5344CB8AC3E}">
-        <p14:creationId xmlns:p14="http://schemas.microsoft.com/office/powerpoint/2010/main" val="3313133360"/>
+        <p14:creationId xmlns:p14="http://schemas.microsoft.com/office/powerpoint/2010/main" val="1023798738"/>
       </p:ext>
     </p:extLst>
   </p:cSld>
@@ -6664,7 +6623,7 @@
           <p:cNvPr id="2" name="TextBox 1">
             <a:extLst>
               <a:ext uri="{FF2B5EF4-FFF2-40B4-BE49-F238E27FC236}">
-                <a16:creationId xmlns:a16="http://schemas.microsoft.com/office/drawing/2014/main" id="{857D0BF5-D90C-9BEC-9237-AD5ECE7BAF8E}"/>
+                <a16:creationId xmlns:a16="http://schemas.microsoft.com/office/drawing/2014/main" id="{AD6C03E5-6385-8BB7-CAE0-81A0C450546F}"/>
               </a:ext>
             </a:extLst>
           </p:cNvPr>
@@ -6710,7 +6669,7 @@
           <p:cNvPr id="3" name="TextBox 2">
             <a:extLst>
               <a:ext uri="{FF2B5EF4-FFF2-40B4-BE49-F238E27FC236}">
-                <a16:creationId xmlns:a16="http://schemas.microsoft.com/office/drawing/2014/main" id="{F6488FC7-A513-7660-4E84-A0A5D499619B}"/>
+                <a16:creationId xmlns:a16="http://schemas.microsoft.com/office/drawing/2014/main" id="{3C1D3CDC-DA29-2533-E078-D72EF8D06451}"/>
               </a:ext>
             </a:extLst>
           </p:cNvPr>
@@ -6756,7 +6715,7 @@
           <p:cNvPr id="4" name="Straight Connector 3">
             <a:extLst>
               <a:ext uri="{FF2B5EF4-FFF2-40B4-BE49-F238E27FC236}">
-                <a16:creationId xmlns:a16="http://schemas.microsoft.com/office/drawing/2014/main" id="{C0EC3ED9-7526-31B1-115E-B868541E2CF2}"/>
+                <a16:creationId xmlns:a16="http://schemas.microsoft.com/office/drawing/2014/main" id="{DB59C3BF-7B94-D50A-4541-CE1AEAE048FA}"/>
               </a:ext>
             </a:extLst>
           </p:cNvPr>
@@ -6797,7 +6756,7 @@
           <p:cNvPr id="5" name="TextBox 4">
             <a:extLst>
               <a:ext uri="{FF2B5EF4-FFF2-40B4-BE49-F238E27FC236}">
-                <a16:creationId xmlns:a16="http://schemas.microsoft.com/office/drawing/2014/main" id="{77006218-ECE4-6E64-948A-37528BB7BB11}"/>
+                <a16:creationId xmlns:a16="http://schemas.microsoft.com/office/drawing/2014/main" id="{F791BB73-7653-2272-DB68-A9A1F2FE43C7}"/>
               </a:ext>
             </a:extLst>
           </p:cNvPr>
@@ -6843,7 +6802,7 @@
           <p:cNvPr id="6" name="Rectangle: Rounded Corners 5">
             <a:extLst>
               <a:ext uri="{FF2B5EF4-FFF2-40B4-BE49-F238E27FC236}">
-                <a16:creationId xmlns:a16="http://schemas.microsoft.com/office/drawing/2014/main" id="{EE657E32-72D2-C404-E023-3A49D1231AC9}"/>
+                <a16:creationId xmlns:a16="http://schemas.microsoft.com/office/drawing/2014/main" id="{963A1B57-9366-9BA9-FDE9-518CF38FD6BF}"/>
               </a:ext>
             </a:extLst>
           </p:cNvPr>
@@ -6899,7 +6858,7 @@
           <p:cNvPr id="7" name="TextBox 6">
             <a:extLst>
               <a:ext uri="{FF2B5EF4-FFF2-40B4-BE49-F238E27FC236}">
-                <a16:creationId xmlns:a16="http://schemas.microsoft.com/office/drawing/2014/main" id="{D41E2E73-D99F-B6AB-2EC7-2792D0B1DAA3}"/>
+                <a16:creationId xmlns:a16="http://schemas.microsoft.com/office/drawing/2014/main" id="{98650933-B486-A662-3638-8BF367A35053}"/>
               </a:ext>
             </a:extLst>
           </p:cNvPr>
@@ -6939,7 +6898,7 @@
           <p:cNvPr id="8" name="TextBox 7">
             <a:extLst>
               <a:ext uri="{FF2B5EF4-FFF2-40B4-BE49-F238E27FC236}">
-                <a16:creationId xmlns:a16="http://schemas.microsoft.com/office/drawing/2014/main" id="{A371BDA2-DC84-6B6A-AE2C-C864729BA706}"/>
+                <a16:creationId xmlns:a16="http://schemas.microsoft.com/office/drawing/2014/main" id="{92063804-7CA4-6EA0-8678-150905438851}"/>
               </a:ext>
             </a:extLst>
           </p:cNvPr>
@@ -6969,7 +6928,7 @@
                 </a:solidFill>
                 <a:latin typeface="Calibri" panose="020F0502020204030204" pitchFamily="34" charset="0"/>
               </a:rPr>
-              <a:t>Interview the owner and observe a full service at the store.</a:t>
+              <a:t>Interview the owner and watch a full service at the store.</a:t>
             </a:r>
           </a:p>
           <a:p>
@@ -6980,7 +6939,7 @@
                 </a:solidFill>
                 <a:latin typeface="Calibri" panose="020F0502020204030204" pitchFamily="34" charset="0"/>
               </a:rPr>
-              <a:t>Design the database and put the ordering rules in PostgreSQL.</a:t>
+              <a:t>Keep the ordering rules in the shop records, not on the phone.</a:t>
             </a:r>
           </a:p>
           <a:p>
@@ -6991,7 +6950,7 @@
                 </a:solidFill>
                 <a:latin typeface="Calibri" panose="020F0502020204030204" pitchFamily="34" charset="0"/>
               </a:rPr>
-              <a:t>Build the customer storefront, the counter screen and the owner dashboard.</a:t>
+              <a:t>Build the diner site, the counter screen and the owner dashboard.</a:t>
             </a:r>
           </a:p>
           <a:p>
@@ -7002,7 +6961,7 @@
                 </a:solidFill>
                 <a:latin typeface="Calibri" panose="020F0502020204030204" pitchFamily="34" charset="0"/>
               </a:rPr>
-              <a:t>Build the proof-of-payment flow and the promotional code engine.</a:t>
+              <a:t>Add accounts, live order tracking, loyalty and stock control.</a:t>
             </a:r>
             <a:endParaRPr lang="en-PH" sz="1100">
               <a:solidFill>
@@ -7018,7 +6977,7 @@
           <p:cNvPr id="9" name="TextBox 8">
             <a:extLst>
               <a:ext uri="{FF2B5EF4-FFF2-40B4-BE49-F238E27FC236}">
-                <a16:creationId xmlns:a16="http://schemas.microsoft.com/office/drawing/2014/main" id="{5B616A72-12A4-D353-7575-9EDFB5A642C8}"/>
+                <a16:creationId xmlns:a16="http://schemas.microsoft.com/office/drawing/2014/main" id="{9EAFB7B0-B88B-A5B8-B8BB-3E4308A66FD4}"/>
               </a:ext>
             </a:extLst>
           </p:cNvPr>
@@ -7064,7 +7023,7 @@
           <p:cNvPr id="10" name="Rectangle: Rounded Corners 9">
             <a:extLst>
               <a:ext uri="{FF2B5EF4-FFF2-40B4-BE49-F238E27FC236}">
-                <a16:creationId xmlns:a16="http://schemas.microsoft.com/office/drawing/2014/main" id="{B4F27938-D3BE-C1B7-1D69-F283882505BB}"/>
+                <a16:creationId xmlns:a16="http://schemas.microsoft.com/office/drawing/2014/main" id="{92E12CC5-E60C-2EC9-9372-96DB8A6A5B14}"/>
               </a:ext>
             </a:extLst>
           </p:cNvPr>
@@ -7120,7 +7079,7 @@
           <p:cNvPr id="11" name="TextBox 10">
             <a:extLst>
               <a:ext uri="{FF2B5EF4-FFF2-40B4-BE49-F238E27FC236}">
-                <a16:creationId xmlns:a16="http://schemas.microsoft.com/office/drawing/2014/main" id="{B388B4E3-47C9-42DD-8479-9B73ABAC9E33}"/>
+                <a16:creationId xmlns:a16="http://schemas.microsoft.com/office/drawing/2014/main" id="{155B3048-7A50-F34A-8694-977B15FB737F}"/>
               </a:ext>
             </a:extLst>
           </p:cNvPr>
@@ -7160,7 +7119,7 @@
           <p:cNvPr id="12" name="TextBox 11">
             <a:extLst>
               <a:ext uri="{FF2B5EF4-FFF2-40B4-BE49-F238E27FC236}">
-                <a16:creationId xmlns:a16="http://schemas.microsoft.com/office/drawing/2014/main" id="{3CB00048-222E-5CBE-9373-E2CC2F69D809}"/>
+                <a16:creationId xmlns:a16="http://schemas.microsoft.com/office/drawing/2014/main" id="{310EECA3-9498-307C-A64F-30075B48DE5A}"/>
               </a:ext>
             </a:extLst>
           </p:cNvPr>
@@ -7190,7 +7149,7 @@
                 </a:solidFill>
                 <a:latin typeface="Calibri" panose="020F0502020204030204" pitchFamily="34" charset="0"/>
               </a:rPr>
-              <a:t>Photograph every dish and write descriptions in Tagalog and English.</a:t>
+              <a:t>Photograph every dish and write Tagalog and English descriptions.</a:t>
             </a:r>
           </a:p>
           <a:p>
@@ -7201,7 +7160,7 @@
                 </a:solidFill>
                 <a:latin typeface="Calibri" panose="020F0502020204030204" pitchFamily="34" charset="0"/>
               </a:rPr>
-              <a:t>Add search visibility and proper link previews.</a:t>
+              <a:t>Make the site findable and give shared links a proper preview.</a:t>
             </a:r>
           </a:p>
           <a:p>
@@ -7212,7 +7171,7 @@
                 </a:solidFill>
                 <a:latin typeface="Calibri" panose="020F0502020204030204" pitchFamily="34" charset="0"/>
               </a:rPr>
-              <a:t>Build the share action, the counter QR and the referral codes.</a:t>
+              <a:t>Build the three mobile apps, the installable app and the QR poster.</a:t>
             </a:r>
           </a:p>
           <a:p>
@@ -7223,7 +7182,7 @@
                 </a:solidFill>
                 <a:latin typeface="Calibri" panose="020F0502020204030204" pitchFamily="34" charset="0"/>
               </a:rPr>
-              <a:t>Deploy the site to free hosting with a public address.</a:t>
+              <a:t>Publish to free hosting with a public address.</a:t>
             </a:r>
             <a:endParaRPr lang="en-PH" sz="1100">
               <a:solidFill>
@@ -7239,7 +7198,7 @@
           <p:cNvPr id="13" name="TextBox 12">
             <a:extLst>
               <a:ext uri="{FF2B5EF4-FFF2-40B4-BE49-F238E27FC236}">
-                <a16:creationId xmlns:a16="http://schemas.microsoft.com/office/drawing/2014/main" id="{6231E59A-3E4D-A5F2-0C50-1FDCE3843D52}"/>
+                <a16:creationId xmlns:a16="http://schemas.microsoft.com/office/drawing/2014/main" id="{70AE2149-1C4F-3BEE-31E8-8B7570220D34}"/>
               </a:ext>
             </a:extLst>
           </p:cNvPr>
@@ -7279,7 +7238,7 @@
           <p:cNvPr id="14" name="Rectangle: Rounded Corners 13">
             <a:extLst>
               <a:ext uri="{FF2B5EF4-FFF2-40B4-BE49-F238E27FC236}">
-                <a16:creationId xmlns:a16="http://schemas.microsoft.com/office/drawing/2014/main" id="{343F4F31-729A-35A3-AACE-8EB0A9F17581}"/>
+                <a16:creationId xmlns:a16="http://schemas.microsoft.com/office/drawing/2014/main" id="{05E0B1BC-1D53-22A2-477E-119D34B4EE81}"/>
               </a:ext>
             </a:extLst>
           </p:cNvPr>
@@ -7335,7 +7294,7 @@
           <p:cNvPr id="15" name="TextBox 14">
             <a:extLst>
               <a:ext uri="{FF2B5EF4-FFF2-40B4-BE49-F238E27FC236}">
-                <a16:creationId xmlns:a16="http://schemas.microsoft.com/office/drawing/2014/main" id="{FAC0D7C7-D316-BC8C-8724-53FDF29316D5}"/>
+                <a16:creationId xmlns:a16="http://schemas.microsoft.com/office/drawing/2014/main" id="{27A4BD1A-84DD-A748-238F-2B1A8F8D7246}"/>
               </a:ext>
             </a:extLst>
           </p:cNvPr>
@@ -7375,7 +7334,7 @@
           <p:cNvPr id="16" name="TextBox 15">
             <a:extLst>
               <a:ext uri="{FF2B5EF4-FFF2-40B4-BE49-F238E27FC236}">
-                <a16:creationId xmlns:a16="http://schemas.microsoft.com/office/drawing/2014/main" id="{6A2CFA76-F331-7D1C-4570-D9A288B68E8D}"/>
+                <a16:creationId xmlns:a16="http://schemas.microsoft.com/office/drawing/2014/main" id="{332B4EB5-5209-2EBA-7B3C-44E0741A9E28}"/>
               </a:ext>
             </a:extLst>
           </p:cNvPr>
@@ -7385,7 +7344,7 @@
         <p:spPr>
           <a:xfrm>
             <a:off x="8356600" y="2692400"/>
-            <a:ext cx="2971800" cy="1354217"/>
+            <a:ext cx="2971800" cy="1184940"/>
           </a:xfrm>
           <a:prstGeom prst="rect">
             <a:avLst/>
@@ -7405,7 +7364,7 @@
                 </a:solidFill>
                 <a:latin typeface="Calibri" panose="020F0502020204030204" pitchFamily="34" charset="0"/>
               </a:rPr>
-              <a:t>Run the three backend test suites and the mobile test suite.</a:t>
+              <a:t>Run the automated checks across the whole system.</a:t>
             </a:r>
           </a:p>
           <a:p>
@@ -7416,7 +7375,7 @@
                 </a:solidFill>
                 <a:latin typeface="Calibri" panose="020F0502020204030204" pitchFamily="34" charset="0"/>
               </a:rPr>
-              <a:t>Walk the whole diner-to-owner path by hand on a phone.</a:t>
+              <a:t>Walk the whole path by hand on a real phone, browsing to collecting.</a:t>
             </a:r>
           </a:p>
           <a:p>
@@ -7454,7 +7413,7 @@
           <p:cNvPr id="17" name="TextBox 16">
             <a:extLst>
               <a:ext uri="{FF2B5EF4-FFF2-40B4-BE49-F238E27FC236}">
-                <a16:creationId xmlns:a16="http://schemas.microsoft.com/office/drawing/2014/main" id="{7323FC6B-E3DB-7612-9084-D02CA3CD773F}"/>
+                <a16:creationId xmlns:a16="http://schemas.microsoft.com/office/drawing/2014/main" id="{6AE41BAD-8CBD-A1E2-2D27-A0238809A3BE}"/>
               </a:ext>
             </a:extLst>
           </p:cNvPr>
@@ -7500,7 +7459,7 @@
           <p:cNvPr id="18" name="TextBox 17">
             <a:extLst>
               <a:ext uri="{FF2B5EF4-FFF2-40B4-BE49-F238E27FC236}">
-                <a16:creationId xmlns:a16="http://schemas.microsoft.com/office/drawing/2014/main" id="{EE3D1D95-D62A-61D5-0CDA-778A2EA7C59D}"/>
+                <a16:creationId xmlns:a16="http://schemas.microsoft.com/office/drawing/2014/main" id="{8020B7EA-DFED-BE17-06BD-70BE79D98ABE}"/>
               </a:ext>
             </a:extLst>
           </p:cNvPr>
@@ -7546,7 +7505,7 @@
           <p:cNvPr id="19" name="TextBox 18">
             <a:extLst>
               <a:ext uri="{FF2B5EF4-FFF2-40B4-BE49-F238E27FC236}">
-                <a16:creationId xmlns:a16="http://schemas.microsoft.com/office/drawing/2014/main" id="{D9DF82AD-2220-8523-95E9-2D722032B7AD}"/>
+                <a16:creationId xmlns:a16="http://schemas.microsoft.com/office/drawing/2014/main" id="{DFED8602-894A-E173-5E46-0B5035C2F07D}"/>
               </a:ext>
             </a:extLst>
           </p:cNvPr>
@@ -7592,7 +7551,7 @@
           <p:cNvPr id="20" name="TextBox 19">
             <a:extLst>
               <a:ext uri="{FF2B5EF4-FFF2-40B4-BE49-F238E27FC236}">
-                <a16:creationId xmlns:a16="http://schemas.microsoft.com/office/drawing/2014/main" id="{DC78A687-2686-3328-A289-6C4F1FC96B7A}"/>
+                <a16:creationId xmlns:a16="http://schemas.microsoft.com/office/drawing/2014/main" id="{1700689B-7AFE-1F5B-E655-7CE48195575F}"/>
               </a:ext>
             </a:extLst>
           </p:cNvPr>
@@ -7630,7 +7589,7 @@
     </p:spTree>
     <p:extLst>
       <p:ext uri="{BB962C8B-B14F-4D97-AF65-F5344CB8AC3E}">
-        <p14:creationId xmlns:p14="http://schemas.microsoft.com/office/powerpoint/2010/main" val="2260014960"/>
+        <p14:creationId xmlns:p14="http://schemas.microsoft.com/office/powerpoint/2010/main" val="2080637076"/>
       </p:ext>
     </p:extLst>
   </p:cSld>
@@ -7670,7 +7629,7 @@
           <p:cNvPr id="2" name="TextBox 1">
             <a:extLst>
               <a:ext uri="{FF2B5EF4-FFF2-40B4-BE49-F238E27FC236}">
-                <a16:creationId xmlns:a16="http://schemas.microsoft.com/office/drawing/2014/main" id="{88397849-2E53-0A49-5E13-3DEAEAF3CBDD}"/>
+                <a16:creationId xmlns:a16="http://schemas.microsoft.com/office/drawing/2014/main" id="{455CCFFA-D61E-A7F3-B02C-428DE9FFBC55}"/>
               </a:ext>
             </a:extLst>
           </p:cNvPr>
@@ -7716,7 +7675,7 @@
           <p:cNvPr id="3" name="TextBox 2">
             <a:extLst>
               <a:ext uri="{FF2B5EF4-FFF2-40B4-BE49-F238E27FC236}">
-                <a16:creationId xmlns:a16="http://schemas.microsoft.com/office/drawing/2014/main" id="{1D706816-51B2-E956-1F36-336DCA48420E}"/>
+                <a16:creationId xmlns:a16="http://schemas.microsoft.com/office/drawing/2014/main" id="{79BD4254-1259-4332-E842-821E53331A15}"/>
               </a:ext>
             </a:extLst>
           </p:cNvPr>
@@ -7762,7 +7721,7 @@
           <p:cNvPr id="4" name="Straight Connector 3">
             <a:extLst>
               <a:ext uri="{FF2B5EF4-FFF2-40B4-BE49-F238E27FC236}">
-                <a16:creationId xmlns:a16="http://schemas.microsoft.com/office/drawing/2014/main" id="{C3791E14-E089-B5C6-2CD1-C87CCF3D8890}"/>
+                <a16:creationId xmlns:a16="http://schemas.microsoft.com/office/drawing/2014/main" id="{0BA16074-B22C-B4B9-554E-AC780FAB3E3E}"/>
               </a:ext>
             </a:extLst>
           </p:cNvPr>
@@ -7803,7 +7762,7 @@
           <p:cNvPr id="5" name="TextBox 4">
             <a:extLst>
               <a:ext uri="{FF2B5EF4-FFF2-40B4-BE49-F238E27FC236}">
-                <a16:creationId xmlns:a16="http://schemas.microsoft.com/office/drawing/2014/main" id="{9FC8EC2E-6745-CC47-8898-15F384FD4EE6}"/>
+                <a16:creationId xmlns:a16="http://schemas.microsoft.com/office/drawing/2014/main" id="{00186A35-F90B-6581-0689-622B6210AB6E}"/>
               </a:ext>
             </a:extLst>
           </p:cNvPr>
@@ -7895,7 +7854,7 @@
           <p:cNvPr id="6" name="TextBox 5">
             <a:extLst>
               <a:ext uri="{FF2B5EF4-FFF2-40B4-BE49-F238E27FC236}">
-                <a16:creationId xmlns:a16="http://schemas.microsoft.com/office/drawing/2014/main" id="{E6FFC930-1E0E-2D38-CB12-A508E461831A}"/>
+                <a16:creationId xmlns:a16="http://schemas.microsoft.com/office/drawing/2014/main" id="{B5F359A1-774B-09BB-6632-6C771288C06B}"/>
               </a:ext>
             </a:extLst>
           </p:cNvPr>
@@ -7905,7 +7864,7 @@
         <p:spPr>
           <a:xfrm>
             <a:off x="6350000" y="1905000"/>
-            <a:ext cx="5080000" cy="2049151"/>
+            <a:ext cx="5080000" cy="1569019"/>
           </a:xfrm>
           <a:prstGeom prst="rect">
             <a:avLst/>
@@ -7933,7 +7892,7 @@
                 </a:solidFill>
                 <a:latin typeface="Calibri" panose="020F0502020204030204" pitchFamily="34" charset="0"/>
               </a:rPr>
-              <a:t>•  Monthly: choose the next promotional code, set its discount and expiry, and announce it.</a:t>
+              <a:t>•  Weekly: publish genuine ratings and reply to any complaint.</a:t>
             </a:r>
           </a:p>
           <a:p>
@@ -7952,7 +7911,7 @@
                 </a:solidFill>
                 <a:latin typeface="Calibri" panose="020F0502020204030204" pitchFamily="34" charset="0"/>
               </a:rPr>
-              <a:t>•  Monthly: export the database and keep the migration history in version control.</a:t>
+              <a:t>•  Monthly: choose the next discount code, set its amount and expiry, and announce it.</a:t>
             </a:r>
           </a:p>
           <a:p>
@@ -7971,7 +7930,7 @@
                 </a:solidFill>
                 <a:latin typeface="Calibri" panose="020F0502020204030204" pitchFamily="34" charset="0"/>
               </a:rPr>
-              <a:t>•  Monthly: re-run the role-separation and security tests, and rotate the staff passwords.</a:t>
+              <a:t>•  Monthly: export the records and keep the change history safe.</a:t>
             </a:r>
           </a:p>
           <a:p>
@@ -7990,7 +7949,7 @@
                 </a:solidFill>
                 <a:latin typeface="Calibri" panose="020F0502020204030204" pitchFamily="34" charset="0"/>
               </a:rPr>
-              <a:t>•  Monthly: confirm the stored payment proofs still fit inside the free tier.</a:t>
+              <a:t>•  Monthly: re-run the access checks and change the staff passwords.</a:t>
             </a:r>
             <a:endParaRPr lang="en-PH" sz="1300">
               <a:solidFill>
@@ -8006,7 +7965,7 @@
           <p:cNvPr id="7" name="TextBox 6">
             <a:extLst>
               <a:ext uri="{FF2B5EF4-FFF2-40B4-BE49-F238E27FC236}">
-                <a16:creationId xmlns:a16="http://schemas.microsoft.com/office/drawing/2014/main" id="{79E20D78-110F-847F-0B5A-65427724C933}"/>
+                <a16:creationId xmlns:a16="http://schemas.microsoft.com/office/drawing/2014/main" id="{9C3C8483-10D0-C1BD-4EB7-1887C01B4525}"/>
               </a:ext>
             </a:extLst>
           </p:cNvPr>
@@ -8052,7 +8011,7 @@
           <p:cNvPr id="8" name="TextBox 7">
             <a:extLst>
               <a:ext uri="{FF2B5EF4-FFF2-40B4-BE49-F238E27FC236}">
-                <a16:creationId xmlns:a16="http://schemas.microsoft.com/office/drawing/2014/main" id="{9CCC5DB8-35B0-8093-D946-B563B2EDDD3E}"/>
+                <a16:creationId xmlns:a16="http://schemas.microsoft.com/office/drawing/2014/main" id="{708911D4-8E77-35B6-06DD-AEE944AADB29}"/>
               </a:ext>
             </a:extLst>
           </p:cNvPr>
@@ -8098,7 +8057,7 @@
           <p:cNvPr id="9" name="TextBox 8">
             <a:extLst>
               <a:ext uri="{FF2B5EF4-FFF2-40B4-BE49-F238E27FC236}">
-                <a16:creationId xmlns:a16="http://schemas.microsoft.com/office/drawing/2014/main" id="{F3FE579B-9570-8C1B-1452-FEB70F6C16E7}"/>
+                <a16:creationId xmlns:a16="http://schemas.microsoft.com/office/drawing/2014/main" id="{270F9021-7508-B09F-DA7B-0197EE69F0FF}"/>
               </a:ext>
             </a:extLst>
           </p:cNvPr>
@@ -8136,7 +8095,7 @@
     </p:spTree>
     <p:extLst>
       <p:ext uri="{BB962C8B-B14F-4D97-AF65-F5344CB8AC3E}">
-        <p14:creationId xmlns:p14="http://schemas.microsoft.com/office/powerpoint/2010/main" val="3044497848"/>
+        <p14:creationId xmlns:p14="http://schemas.microsoft.com/office/powerpoint/2010/main" val="3997399505"/>
       </p:ext>
     </p:extLst>
   </p:cSld>
@@ -8176,7 +8135,7 @@
           <p:cNvPr id="2" name="TextBox 1">
             <a:extLst>
               <a:ext uri="{FF2B5EF4-FFF2-40B4-BE49-F238E27FC236}">
-                <a16:creationId xmlns:a16="http://schemas.microsoft.com/office/drawing/2014/main" id="{AE767F43-176A-65AD-2B64-06AB9EFA6A2B}"/>
+                <a16:creationId xmlns:a16="http://schemas.microsoft.com/office/drawing/2014/main" id="{1AFDCD85-D509-E1F1-8F9C-AD821B33AE6A}"/>
               </a:ext>
             </a:extLst>
           </p:cNvPr>
@@ -8216,7 +8175,7 @@
           <p:cNvPr id="3" name="TextBox 2">
             <a:extLst>
               <a:ext uri="{FF2B5EF4-FFF2-40B4-BE49-F238E27FC236}">
-                <a16:creationId xmlns:a16="http://schemas.microsoft.com/office/drawing/2014/main" id="{896B385F-7870-C430-0559-E665DDE1856C}"/>
+                <a16:creationId xmlns:a16="http://schemas.microsoft.com/office/drawing/2014/main" id="{995E56EC-122D-6D4E-F25E-749203A877C7}"/>
               </a:ext>
             </a:extLst>
           </p:cNvPr>
@@ -8273,7 +8232,7 @@
           <p:cNvPr id="4" name="Straight Connector 3">
             <a:extLst>
               <a:ext uri="{FF2B5EF4-FFF2-40B4-BE49-F238E27FC236}">
-                <a16:creationId xmlns:a16="http://schemas.microsoft.com/office/drawing/2014/main" id="{CDD4334E-923E-90E1-6ABB-2C7179790421}"/>
+                <a16:creationId xmlns:a16="http://schemas.microsoft.com/office/drawing/2014/main" id="{5E9285E8-2B9E-6F54-D3E8-3AA02313AD29}"/>
               </a:ext>
             </a:extLst>
           </p:cNvPr>
@@ -8314,7 +8273,7 @@
           <p:cNvPr id="5" name="TextBox 4">
             <a:extLst>
               <a:ext uri="{FF2B5EF4-FFF2-40B4-BE49-F238E27FC236}">
-                <a16:creationId xmlns:a16="http://schemas.microsoft.com/office/drawing/2014/main" id="{A704425E-FFB6-3488-6EFF-130803546AF6}"/>
+                <a16:creationId xmlns:a16="http://schemas.microsoft.com/office/drawing/2014/main" id="{5B7E5C7C-E7AF-D476-8400-80EFE0921720}"/>
               </a:ext>
             </a:extLst>
           </p:cNvPr>
@@ -8360,7 +8319,7 @@
           <p:cNvPr id="6" name="TextBox 5">
             <a:extLst>
               <a:ext uri="{FF2B5EF4-FFF2-40B4-BE49-F238E27FC236}">
-                <a16:creationId xmlns:a16="http://schemas.microsoft.com/office/drawing/2014/main" id="{8FCF46AF-1A25-B9DA-BA6E-2C14BD4D803F}"/>
+                <a16:creationId xmlns:a16="http://schemas.microsoft.com/office/drawing/2014/main" id="{20D7C5B2-F3F4-4F6E-38A0-DB972FE54D5C}"/>
               </a:ext>
             </a:extLst>
           </p:cNvPr>
@@ -8398,7 +8357,7 @@
     </p:spTree>
     <p:extLst>
       <p:ext uri="{BB962C8B-B14F-4D97-AF65-F5344CB8AC3E}">
-        <p14:creationId xmlns:p14="http://schemas.microsoft.com/office/powerpoint/2010/main" val="2488551798"/>
+        <p14:creationId xmlns:p14="http://schemas.microsoft.com/office/powerpoint/2010/main" val="838567287"/>
       </p:ext>
     </p:extLst>
   </p:cSld>

</xml_diff>